<commit_message>
Implement PADR model and phenological time alignment for big onion yield prediction
- Added `padr.py`: Introduced the Phenology-Aligned Differentiable Response (PADR) model for estimating onion yield based on thermal phenological time and weather data.
- Added `phenology.py`: Developed a method to align crop development with thermal time, utilizing harvest dates and accumulated heat for accurate predictions.
- Created `run_padr.py`: Implemented a script to fit the PADR model using leave-one-year-out validation and compare results against baseline models.
- Introduced `variance_decomposition.py`: Analyzed the sources of variance in onion yield data, including year and district effects, measurement error, and their implications for model performance.
- Enhanced documentation and comments throughout the code for clarity and understanding of the model's functionality and methodology.
</commit_message>
<xml_diff>
--- a/outputs/Final_Presentation_AgroAI.pptx
+++ b/outputs/Final_Presentation_AgroAI.pptx
@@ -603,7 +603,7 @@
           <a:lstStyle/>
           <a:p>
             <a:r>
-              <a:t>Flag the two novelty rows now; the next two slides open them up.</a:t>
+              <a:t>The two reference rows matter more than the models. Without the oracle row nobody can tell whether a negative score is the model's fault or the protocol's.</a:t>
             </a:r>
           </a:p>
         </p:txBody>
@@ -673,7 +673,7 @@
           <a:lstStyle/>
           <a:p>
             <a:r>
-              <a:t>If asked why not a full crop simulator like APSIM: it needs parameterisation and calibration data we do not have. Our backbone is three lines of arithmetic and gets a measurable part of the same benefit.</a:t>
+              <a:t>The distinction to hammer: Shahhosseini et al. run a crop model with published coefficients and fit a learner to the residual. We estimate the coefficients. That is a method claim, not a domain claim, and it is what the supervisor asked for.</a:t>
             </a:r>
           </a:p>
         </p:txBody>
@@ -743,7 +743,7 @@
           <a:lstStyle/>
           <a:p>
             <a:r>
-              <a:t>The data-efficiency argument: separate per-season models would halve the sample per parameter. Appending season to the input would let the filters specialise on season and dissipate the same advantage more subtly. IMPORTANT — be upfront that the collected data is Yala-only, so this specific claim is tested on synthetic data, not real. Do not oversell it.</a:t>
+              <a:t>If asked why not NDVI: it is an area argument, not a sensor argument. A crop on 0.1% of the pixels cannot move a district mean. We tried it, measured the failure, and report it.</a:t>
             </a:r>
           </a:p>
         </p:txBody>
@@ -813,7 +813,7 @@
           <a:lstStyle/>
           <a:p>
             <a:r>
-              <a:t>This is the most important methodological slide. If a panel member questions the low R², return here.</a:t>
+              <a:t>This slide is our insurance. Every low number later is a consequence of choices defended here.</a:t>
             </a:r>
           </a:p>
         </p:txBody>
@@ -883,7 +883,7 @@
           <a:lstStyle/>
           <a:p>
             <a:r>
-              <a:t>Do not apologise for this. State it as a finding about the domain: this is how much trustworthy data exists for this crop. The Yala-only limitation is what prevents us validating the season-injection claim on real data — say so before anyone asks.</a:t>
+              <a:t>Lead with this. It is the least comfortable slide and the most credible one. A panel that sees us find and report our own contamination will trust everything that follows.</a:t>
             </a:r>
           </a:p>
         </p:txBody>
@@ -953,7 +953,7 @@
           <a:lstStyle/>
           <a:p>
             <a:r>
-              <a:t>Two things to say. First, the winner is the physics hybrid — the novelty pays. Second, the whole deep family is below the baseline and the two convolutional models are catastrophic at R² near −7.</a:t>
+              <a:t>This is the single most important slide in the deck. The proposal target was set before anyone knew the structure of the record. No model of any architecture could have reached 0.75 here. Say the number: the ceiling is 0.162.</a:t>
             </a:r>
           </a:p>
         </p:txBody>
@@ -1023,7 +1023,7 @@
           <a:lstStyle/>
           <a:p>
             <a:r>
-              <a:t>Own this result rather than defending it. The published hybrid architectures are validated on datasets three orders of magnitude larger. Showing where the advantage disappears is a genuine contribution.</a:t>
+              <a:t>Do not apologise for this slide. Read against the ceiling it is the expected outcome, and the next slide explains the mechanism.</a:t>
             </a:r>
           </a:p>
         </p:txBody>
@@ -1093,7 +1093,7 @@
           <a:lstStyle/>
           <a:p>
             <a:r>
-              <a:t>The mechanism matters more than the magnitude. The backbone helps not because it is accurate — it is not — but because it removes work from the learner. Honest caveat: heat stress days are zero throughout the Yala data, so the benefit comes from thermal time and water only.</a:t>
+              <a:t>The key sentence: a model whose output varies eight per cent cannot explain a target that varies thirty-five, whatever coefficients you give it. This is structural, not a tuning failure. And removing 2022 and 2024 makes it relatively WORSE, so the signal is absent, not masked.</a:t>
             </a:r>
           </a:p>
         </p:txBody>
@@ -1163,7 +1163,7 @@
           <a:lstStyle/>
           <a:p>
             <a:r>
-              <a:t>The convex optimiser assigned 0.399 to the physics hybrid and exactly zero to the CNN — an independent confirmation of Finding 2 by a completely different route. We report this as a negative result and serve the single model, not the stack.</a:t>
+              <a:t>This is the slide that turns 'our model failed' into 'the signal is not there'. A negative result from an underpowered instrument says nothing about the world; this measures the instrument. Two honesty points if pressed: the curve is non-monotonic because we ran only two replicates per amplitude, and we used a single optimiser start from the literature values — which is deliberately OPTIMISTIC, so failing to detect under those conditions errs the safe way.</a:t>
             </a:r>
           </a:p>
         </p:txBody>
@@ -1233,7 +1233,7 @@
           <a:lstStyle/>
           <a:p>
             <a:r>
-              <a:t>Two honest readings. Soil alone looks strongest among single sources, but static per-district features act as a district identifier — that is a baseline effect, not soil science. And weather+satellite is worse than either alone: adding features adds variance faster than information. Textbook curse of dimensionality, made visible.</a:t>
+              <a:t>Strongest positive result, and transferable: learning the constants does not add explanatory power so much as REMOVE spurious sensitivity — stress CV falls 22.4% to 8.1% while R² improves 0.57. IMPORTANT CAVEAT: our recovery experiment shows Ky returns its prior (1.108) when fitted to data generated with 0.966. The tight fold spread on Ky was the shrinkage prior, not evidence — precision without accuracy. So we claim T_opt and W_max, not Ky. The FAO-overstatement finding survives because it rests on the ablation contrast, not on any single point estimate.</a:t>
             </a:r>
           </a:p>
         </p:txBody>
@@ -1373,7 +1373,7 @@
           <a:lstStyle/>
           <a:p>
             <a:r>
-              <a:t>Explain the apparent contradiction — it is a good sign of understanding. R² is normalised by each district's own variance and Kurunegala's spread is narrowest, so a moderate absolute error consumes a large share of a small variance. For an operational user, absolute error is what matters.</a:t>
+              <a:t>Volunteer the nulls. An ablation in which every proposed component happens to help is not a credible ablation, and a panel knows it. Thermal time is negligible because temperature barely varies here; waterlogging binds in 3.5% of intervals in one year.</a:t>
             </a:r>
           </a:p>
         </p:txBody>
@@ -1443,7 +1443,7 @@
           <a:lstStyle/>
           <a:p>
             <a:r>
-              <a:t>This validates the feature engineering directly. In a regime where the model cannot discover interactions from data, the interactions have to be supplied. Caveat if pressed: attributions describe what the fitted model does, not necessarily what nature does.</a:t>
+              <a:t>Hedge this one appropriately: the underlying stress signal is weak, so the curve is estimated from little information. The shape is stable across folds and agronomically plausible for a crop whose bulb is set early, but it is not a well-identified estimate.</a:t>
             </a:r>
           </a:p>
         </p:txBody>
@@ -1513,7 +1513,7 @@
           <a:lstStyle/>
           <a:p>
             <a:r>
-              <a:t>Be honest about the coverage figure: empirical coverage is 1.00 because we calibrate and measure on the same 28 residuals, and the finite-sample correction lands near the maximum residual. The intervals are conservative, not tight. But a wide honest interval beats a narrow dishonest one — ±6.85 on a mean of 16.39 tells a planner to hedge.</a:t>
+              <a:t>The interim report said coverage was 1.000 for all twelve models. That was a tautology — the quantile was computed from the same residuals it was then measured on. Year-blocked cross-conformal gives 0.911 against a nominal 0.90. But the width is the finding: plus or minus 15.3 on a mean of 17.9 is plus or minus 85%. These forecasts are not decision-useful, and the interval is the evidence for saying so.</a:t>
             </a:r>
           </a:p>
         </p:txBody>
@@ -1583,7 +1583,7 @@
           <a:lstStyle/>
           <a:p>
             <a:r>
-              <a:t>This is the answer to 'is your low R² a bug?'. Identical pipeline, identical code, only the input differs. 0.020 on 28 records becomes 0.842 on ~160. The limiting factor is the sample, not the implementation. Be scrupulous that this bar is labelled synthetic.</a:t>
+              <a:t>Expect a question here. The answer: we found these ourselves, before submission, by auditing our own inputs. That is the process working.</a:t>
             </a:r>
           </a:p>
         </p:txBody>
@@ -1653,7 +1653,7 @@
           <a:lstStyle/>
           <a:p>
             <a:r>
-              <a:t>Note gap 4 honestly — design contributed, validation incomplete. A panel will respect the distinction far more than an overclaim, and they will find it anyway.</a:t>
+              <a:t>Note that four of five contributions are things we found by being sceptical of our own pipeline. That is the story of this project.</a:t>
             </a:r>
           </a:p>
         </p:txBody>
@@ -1723,7 +1723,7 @@
           <a:lstStyle/>
           <a:p>
             <a:r>
-              <a:t>Leading with limitations is a strength in a defence. Every one of these is specific and most trace back to sample size. The lead-time point is the one a practitioner would actually raise: we currently use full-season predictors.</a:t>
+              <a:t>The first item is the real conclusion. Our finding tells the next person exactly what to collect, and it is not more weather data.</a:t>
             </a:r>
           </a:p>
         </p:txBody>
@@ -1793,7 +1793,7 @@
           <a:lstStyle/>
           <a:p>
             <a:r>
-              <a:t>Land on the framing: for a crop on which national import decisions turn and for which no forecast exists at all, a calibrated and explainable pre-harvest estimate with a stated interval is worth having. We established that it can be built and what it will take to make it good.</a:t>
+              <a:t>Land here. We did not get the number we wanted. We got something more useful: an explanation of why that number was never available, and a clear statement of what the next person should collect.</a:t>
             </a:r>
           </a:p>
         </p:txBody>
@@ -6880,7 +6880,7 @@
                 </a:solidFill>
                 <a:latin typeface="Helvetica Neue"/>
               </a:rPr>
-              <a:t>32 engineered predictors</a:t>
+              <a:t>Engineered predictors, after the cull</a:t>
             </a:r>
           </a:p>
         </p:txBody>
@@ -7630,7 +7630,7 @@
                 </a:solidFill>
                 <a:latin typeface="Helvetica Neue"/>
               </a:rPr>
-              <a:t>Nine models, one protocol</a:t>
+              <a:t>What we compare, and against what</a:t>
             </a:r>
           </a:p>
         </p:txBody>
@@ -7645,7 +7645,7 @@
         </p:nvGraphicFramePr>
         <p:xfrm>
           <a:off x="777240" y="1920240"/>
-          <a:ext cx="10637214" cy="3611880"/>
+          <a:ext cx="10637213" cy="3072384"/>
         </p:xfrm>
         <a:graphic>
           <a:graphicData uri="http://schemas.openxmlformats.org/drawingml/2006/table">
@@ -7654,11 +7654,11 @@
                 <a:tableStyleId>{5C22544A-7EE6-4342-B048-85BDC9FD1C3A}</a:tableStyleId>
               </a:tblPr>
               <a:tblGrid>
-                <a:gridCol w="2687296"/>
-                <a:gridCol w="2463355"/>
-                <a:gridCol w="5486563"/>
+                <a:gridCol w="2911237"/>
+                <a:gridCol w="2575325"/>
+                <a:gridCol w="5150651"/>
               </a:tblGrid>
-              <a:tr h="361188">
+              <a:tr h="384048">
                 <a:tc>
                   <a:txBody>
                     <a:bodyPr wrap="square"/>
@@ -7729,7 +7729,149 @@
                   </a:tcPr>
                 </a:tc>
               </a:tr>
-              <a:tr h="361188">
+              <a:tr h="384048">
+                <a:tc>
+                  <a:txBody>
+                    <a:bodyPr wrap="square"/>
+                    <a:lstStyle/>
+                    <a:p>
+                      <a:pPr algn="l"/>
+                      <a:r>
+                        <a:rPr sz="1150" b="0" i="0">
+                          <a:solidFill>
+                            <a:srgbClr val="52514E"/>
+                          </a:solidFill>
+                          <a:latin typeface="Helvetica Neue"/>
+                        </a:rPr>
+                        <a:t>Train mean</a:t>
+                      </a:r>
+                    </a:p>
+                  </a:txBody>
+                  <a:tcPr marL="91440" marR="91440">
+                    <a:solidFill>
+                      <a:srgbClr val="F7F6F4"/>
+                    </a:solidFill>
+                  </a:tcPr>
+                </a:tc>
+                <a:tc>
+                  <a:txBody>
+                    <a:bodyPr wrap="square"/>
+                    <a:lstStyle/>
+                    <a:p>
+                      <a:pPr algn="l"/>
+                      <a:r>
+                        <a:rPr sz="1150" b="0" i="0">
+                          <a:solidFill>
+                            <a:srgbClr val="52514E"/>
+                          </a:solidFill>
+                          <a:latin typeface="Helvetica Neue"/>
+                        </a:rPr>
+                        <a:t>Naive</a:t>
+                      </a:r>
+                    </a:p>
+                  </a:txBody>
+                  <a:tcPr marL="91440" marR="91440">
+                    <a:solidFill>
+                      <a:srgbClr val="F7F6F4"/>
+                    </a:solidFill>
+                  </a:tcPr>
+                </a:tc>
+                <a:tc>
+                  <a:txBody>
+                    <a:bodyPr wrap="square"/>
+                    <a:lstStyle/>
+                    <a:p>
+                      <a:pPr algn="l"/>
+                      <a:r>
+                        <a:rPr sz="1150" b="0" i="0">
+                          <a:solidFill>
+                            <a:srgbClr val="52514E"/>
+                          </a:solidFill>
+                          <a:latin typeface="Helvetica Neue"/>
+                        </a:rPr>
+                        <a:t>THE BAR — best available without knowing the held-out year</a:t>
+                      </a:r>
+                    </a:p>
+                  </a:txBody>
+                  <a:tcPr marL="91440" marR="91440">
+                    <a:solidFill>
+                      <a:srgbClr val="F7F6F4"/>
+                    </a:solidFill>
+                  </a:tcPr>
+                </a:tc>
+              </a:tr>
+              <a:tr h="384048">
+                <a:tc>
+                  <a:txBody>
+                    <a:bodyPr wrap="square"/>
+                    <a:lstStyle/>
+                    <a:p>
+                      <a:pPr algn="l"/>
+                      <a:r>
+                        <a:rPr sz="1150" b="0" i="0">
+                          <a:solidFill>
+                            <a:srgbClr val="52514E"/>
+                          </a:solidFill>
+                          <a:latin typeface="Helvetica Neue"/>
+                        </a:rPr>
+                        <a:t>Oracle year-mean</a:t>
+                      </a:r>
+                    </a:p>
+                  </a:txBody>
+                  <a:tcPr marL="91440" marR="91440">
+                    <a:solidFill>
+                      <a:srgbClr val="FCFCFB"/>
+                    </a:solidFill>
+                  </a:tcPr>
+                </a:tc>
+                <a:tc>
+                  <a:txBody>
+                    <a:bodyPr wrap="square"/>
+                    <a:lstStyle/>
+                    <a:p>
+                      <a:pPr algn="l"/>
+                      <a:r>
+                        <a:rPr sz="1150" b="0" i="0">
+                          <a:solidFill>
+                            <a:srgbClr val="52514E"/>
+                          </a:solidFill>
+                          <a:latin typeface="Helvetica Neue"/>
+                        </a:rPr>
+                        <a:t>Reference</a:t>
+                      </a:r>
+                    </a:p>
+                  </a:txBody>
+                  <a:tcPr marL="91440" marR="91440">
+                    <a:solidFill>
+                      <a:srgbClr val="FCFCFB"/>
+                    </a:solidFill>
+                  </a:tcPr>
+                </a:tc>
+                <a:tc>
+                  <a:txBody>
+                    <a:bodyPr wrap="square"/>
+                    <a:lstStyle/>
+                    <a:p>
+                      <a:pPr algn="l"/>
+                      <a:r>
+                        <a:rPr sz="1150" b="0" i="0">
+                          <a:solidFill>
+                            <a:srgbClr val="52514E"/>
+                          </a:solidFill>
+                          <a:latin typeface="Helvetica Neue"/>
+                        </a:rPr>
+                        <a:t>NOT ACHIEVABLE — bounds what perfect year knowledge buys</a:t>
+                      </a:r>
+                    </a:p>
+                  </a:txBody>
+                  <a:tcPr marL="91440" marR="91440">
+                    <a:solidFill>
+                      <a:srgbClr val="FCFCFB"/>
+                    </a:solidFill>
+                  </a:tcPr>
+                </a:tc>
+              </a:tr>
+              <a:tr h="384048">
                 <a:tc>
                   <a:txBody>
                     <a:bodyPr wrap="square"/>
@@ -7800,7 +7942,7 @@
                   </a:tcPr>
                 </a:tc>
               </a:tr>
-              <a:tr h="361188">
+              <a:tr h="384048">
                 <a:tc>
                   <a:txBody>
                     <a:bodyPr wrap="square"/>
@@ -7871,7 +8013,7 @@
                   </a:tcPr>
                 </a:tc>
               </a:tr>
-              <a:tr h="361188">
+              <a:tr h="384048">
                 <a:tc>
                   <a:txBody>
                     <a:bodyPr wrap="square"/>
@@ -7942,7 +8084,7 @@
                   </a:tcPr>
                 </a:tc>
               </a:tr>
-              <a:tr h="361188">
+              <a:tr h="384048">
                 <a:tc>
                   <a:txBody>
                     <a:bodyPr wrap="square"/>
@@ -7956,7 +8098,7 @@
                           </a:solidFill>
                           <a:latin typeface="Helvetica Neue"/>
                         </a:rPr>
-                        <a:t>LSTM / BiLSTM</a:t>
+                        <a:t>District mean / persistence</a:t>
                       </a:r>
                     </a:p>
                   </a:txBody>
@@ -7979,7 +8121,7 @@
                           </a:solidFill>
                           <a:latin typeface="Helvetica Neue"/>
                         </a:rPr>
-                        <a:t>Recurrent</a:t>
+                        <a:t>Naive</a:t>
                       </a:r>
                     </a:p>
                   </a:txBody>
@@ -8002,7 +8144,7 @@
                           </a:solidFill>
                           <a:latin typeface="Helvetica Neue"/>
                         </a:rPr>
-                        <a:t>Temporal integration of the weather sequence</a:t>
+                        <a:t>Do district identity or last year carry the signal?</a:t>
                       </a:r>
                     </a:p>
                   </a:txBody>
@@ -8013,7 +8155,7 @@
                   </a:tcPr>
                 </a:tc>
               </a:tr>
-              <a:tr h="361188">
+              <a:tr h="384048">
                 <a:tc>
                   <a:txBody>
                     <a:bodyPr wrap="square"/>
@@ -8027,7 +8169,7 @@
                           </a:solidFill>
                           <a:latin typeface="Helvetica Neue"/>
                         </a:rPr>
-                        <a:t>1D-CNN</a:t>
+                        <a:t>PADR</a:t>
                       </a:r>
                     </a:p>
                   </a:txBody>
@@ -8050,7 +8192,7 @@
                           </a:solidFill>
                           <a:latin typeface="Helvetica Neue"/>
                         </a:rPr>
-                        <a:t>Convolutional</a:t>
+                        <a:t>Mechanistic, estimated</a:t>
                       </a:r>
                     </a:p>
                   </a:txBody>
@@ -8073,291 +8215,7 @@
                           </a:solidFill>
                           <a:latin typeface="Helvetica Neue"/>
                         </a:rPr>
-                        <a:t>Local shape of the NDVI trajectory</a:t>
-                      </a:r>
-                    </a:p>
-                  </a:txBody>
-                  <a:tcPr marL="91440" marR="91440">
-                    <a:solidFill>
-                      <a:srgbClr val="F7F6F4"/>
-                    </a:solidFill>
-                  </a:tcPr>
-                </a:tc>
-              </a:tr>
-              <a:tr h="361188">
-                <a:tc>
-                  <a:txBody>
-                    <a:bodyPr wrap="square"/>
-                    <a:lstStyle/>
-                    <a:p>
-                      <a:pPr algn="l"/>
-                      <a:r>
-                        <a:rPr sz="1150" b="0" i="0">
-                          <a:solidFill>
-                            <a:srgbClr val="52514E"/>
-                          </a:solidFill>
-                          <a:latin typeface="Helvetica Neue"/>
-                        </a:rPr>
-                        <a:t>Hybrid CNN-LSTM</a:t>
-                      </a:r>
-                    </a:p>
-                  </a:txBody>
-                  <a:tcPr marL="91440" marR="91440">
-                    <a:solidFill>
-                      <a:srgbClr val="FCFCFB"/>
-                    </a:solidFill>
-                  </a:tcPr>
-                </a:tc>
-                <a:tc>
-                  <a:txBody>
-                    <a:bodyPr wrap="square"/>
-                    <a:lstStyle/>
-                    <a:p>
-                      <a:pPr algn="l"/>
-                      <a:r>
-                        <a:rPr sz="1150" b="0" i="0">
-                          <a:solidFill>
-                            <a:srgbClr val="52514E"/>
-                          </a:solidFill>
-                          <a:latin typeface="Helvetica Neue"/>
-                        </a:rPr>
-                        <a:t>Two-branch</a:t>
-                      </a:r>
-                    </a:p>
-                  </a:txBody>
-                  <a:tcPr marL="91440" marR="91440">
-                    <a:solidFill>
-                      <a:srgbClr val="FCFCFB"/>
-                    </a:solidFill>
-                  </a:tcPr>
-                </a:tc>
-                <a:tc>
-                  <a:txBody>
-                    <a:bodyPr wrap="square"/>
-                    <a:lstStyle/>
-                    <a:p>
-                      <a:pPr algn="l"/>
-                      <a:r>
-                        <a:rPr sz="1150" b="0" i="0">
-                          <a:solidFill>
-                            <a:srgbClr val="52514E"/>
-                          </a:solidFill>
-                          <a:latin typeface="Helvetica Neue"/>
-                        </a:rPr>
-                        <a:t>NOVELTY — season injected after feature extraction</a:t>
-                      </a:r>
-                    </a:p>
-                  </a:txBody>
-                  <a:tcPr marL="91440" marR="91440">
-                    <a:solidFill>
-                      <a:srgbClr val="FCFCFB"/>
-                    </a:solidFill>
-                  </a:tcPr>
-                </a:tc>
-              </a:tr>
-              <a:tr h="361188">
-                <a:tc>
-                  <a:txBody>
-                    <a:bodyPr wrap="square"/>
-                    <a:lstStyle/>
-                    <a:p>
-                      <a:pPr algn="l"/>
-                      <a:r>
-                        <a:rPr sz="1150" b="0" i="0">
-                          <a:solidFill>
-                            <a:srgbClr val="52514E"/>
-                          </a:solidFill>
-                          <a:latin typeface="Helvetica Neue"/>
-                        </a:rPr>
-                        <a:t>Symbolic regression</a:t>
-                      </a:r>
-                    </a:p>
-                  </a:txBody>
-                  <a:tcPr marL="91440" marR="91440">
-                    <a:solidFill>
-                      <a:srgbClr val="F7F6F4"/>
-                    </a:solidFill>
-                  </a:tcPr>
-                </a:tc>
-                <a:tc>
-                  <a:txBody>
-                    <a:bodyPr wrap="square"/>
-                    <a:lstStyle/>
-                    <a:p>
-                      <a:pPr algn="l"/>
-                      <a:r>
-                        <a:rPr sz="1150" b="0" i="0">
-                          <a:solidFill>
-                            <a:srgbClr val="52514E"/>
-                          </a:solidFill>
-                          <a:latin typeface="Helvetica Neue"/>
-                        </a:rPr>
-                        <a:t>Genetic programming</a:t>
-                      </a:r>
-                    </a:p>
-                  </a:txBody>
-                  <a:tcPr marL="91440" marR="91440">
-                    <a:solidFill>
-                      <a:srgbClr val="F7F6F4"/>
-                    </a:solidFill>
-                  </a:tcPr>
-                </a:tc>
-                <a:tc>
-                  <a:txBody>
-                    <a:bodyPr wrap="square"/>
-                    <a:lstStyle/>
-                    <a:p>
-                      <a:pPr algn="l"/>
-                      <a:r>
-                        <a:rPr sz="1150" b="0" i="0">
-                          <a:solidFill>
-                            <a:srgbClr val="52514E"/>
-                          </a:solidFill>
-                          <a:latin typeface="Helvetica Neue"/>
-                        </a:rPr>
-                        <a:t>A human-readable closed-form equation</a:t>
-                      </a:r>
-                    </a:p>
-                  </a:txBody>
-                  <a:tcPr marL="91440" marR="91440">
-                    <a:solidFill>
-                      <a:srgbClr val="F7F6F4"/>
-                    </a:solidFill>
-                  </a:tcPr>
-                </a:tc>
-              </a:tr>
-              <a:tr h="361188">
-                <a:tc>
-                  <a:txBody>
-                    <a:bodyPr wrap="square"/>
-                    <a:lstStyle/>
-                    <a:p>
-                      <a:pPr algn="l"/>
-                      <a:r>
-                        <a:rPr sz="1150" b="0" i="0">
-                          <a:solidFill>
-                            <a:srgbClr val="52514E"/>
-                          </a:solidFill>
-                          <a:latin typeface="Helvetica Neue"/>
-                        </a:rPr>
-                        <a:t>Physics-residual</a:t>
-                      </a:r>
-                    </a:p>
-                  </a:txBody>
-                  <a:tcPr marL="91440" marR="91440">
-                    <a:solidFill>
-                      <a:srgbClr val="FCFCFB"/>
-                    </a:solidFill>
-                  </a:tcPr>
-                </a:tc>
-                <a:tc>
-                  <a:txBody>
-                    <a:bodyPr wrap="square"/>
-                    <a:lstStyle/>
-                    <a:p>
-                      <a:pPr algn="l"/>
-                      <a:r>
-                        <a:rPr sz="1150" b="0" i="0">
-                          <a:solidFill>
-                            <a:srgbClr val="52514E"/>
-                          </a:solidFill>
-                          <a:latin typeface="Helvetica Neue"/>
-                        </a:rPr>
-                        <a:t>Mechanistic + ML</a:t>
-                      </a:r>
-                    </a:p>
-                  </a:txBody>
-                  <a:tcPr marL="91440" marR="91440">
-                    <a:solidFill>
-                      <a:srgbClr val="FCFCFB"/>
-                    </a:solidFill>
-                  </a:tcPr>
-                </a:tc>
-                <a:tc>
-                  <a:txBody>
-                    <a:bodyPr wrap="square"/>
-                    <a:lstStyle/>
-                    <a:p>
-                      <a:pPr algn="l"/>
-                      <a:r>
-                        <a:rPr sz="1150" b="0" i="0">
-                          <a:solidFill>
-                            <a:srgbClr val="52514E"/>
-                          </a:solidFill>
-                          <a:latin typeface="Helvetica Neue"/>
-                        </a:rPr>
-                        <a:t>NOVELTY — agronomic prior plus learned residual</a:t>
-                      </a:r>
-                    </a:p>
-                  </a:txBody>
-                  <a:tcPr marL="91440" marR="91440">
-                    <a:solidFill>
-                      <a:srgbClr val="FCFCFB"/>
-                    </a:solidFill>
-                  </a:tcPr>
-                </a:tc>
-              </a:tr>
-              <a:tr h="361188">
-                <a:tc>
-                  <a:txBody>
-                    <a:bodyPr wrap="square"/>
-                    <a:lstStyle/>
-                    <a:p>
-                      <a:pPr algn="l"/>
-                      <a:r>
-                        <a:rPr sz="1150" b="0" i="0">
-                          <a:solidFill>
-                            <a:srgbClr val="52514E"/>
-                          </a:solidFill>
-                          <a:latin typeface="Helvetica Neue"/>
-                        </a:rPr>
-                        <a:t>Convex stacking</a:t>
-                      </a:r>
-                    </a:p>
-                  </a:txBody>
-                  <a:tcPr marL="91440" marR="91440">
-                    <a:solidFill>
-                      <a:srgbClr val="F7F6F4"/>
-                    </a:solidFill>
-                  </a:tcPr>
-                </a:tc>
-                <a:tc>
-                  <a:txBody>
-                    <a:bodyPr wrap="square"/>
-                    <a:lstStyle/>
-                    <a:p>
-                      <a:pPr algn="l"/>
-                      <a:r>
-                        <a:rPr sz="1150" b="0" i="0">
-                          <a:solidFill>
-                            <a:srgbClr val="52514E"/>
-                          </a:solidFill>
-                          <a:latin typeface="Helvetica Neue"/>
-                        </a:rPr>
-                        <a:t>Ensemble</a:t>
-                      </a:r>
-                    </a:p>
-                  </a:txBody>
-                  <a:tcPr marL="91440" marR="91440">
-                    <a:solidFill>
-                      <a:srgbClr val="F7F6F4"/>
-                    </a:solidFill>
-                  </a:tcPr>
-                </a:tc>
-                <a:tc>
-                  <a:txBody>
-                    <a:bodyPr wrap="square"/>
-                    <a:lstStyle/>
-                    <a:p>
-                      <a:pPr algn="l"/>
-                      <a:r>
-                        <a:rPr sz="1150" b="0" i="0">
-                          <a:solidFill>
-                            <a:srgbClr val="52514E"/>
-                          </a:solidFill>
-                          <a:latin typeface="Helvetica Neue"/>
-                        </a:rPr>
-                        <a:t>Constrained blend of all of the above</a:t>
+                        <a:t>THE METHOD — 17 parameters, constants fitted from data</a:t>
                       </a:r>
                     </a:p>
                   </a:txBody>
@@ -8521,7 +8379,7 @@
                 </a:solidFill>
                 <a:latin typeface="Helvetica Neue"/>
               </a:rPr>
-              <a:t>Two novelties</a:t>
+              <a:t>The method</a:t>
             </a:r>
           </a:p>
         </p:txBody>
@@ -8566,7 +8424,7 @@
                 </a:solidFill>
                 <a:latin typeface="Helvetica Neue"/>
               </a:rPr>
-              <a:t>One asks what to do when there is not enough data to learn from. The other asks how to represent two monsoon seasons in one network.</a:t>
+              <a:t>A seventeen-parameter agronomic response model whose crop constants are estimated from data rather than assumed.</a:t>
             </a:r>
           </a:p>
         </p:txBody>
@@ -8678,7 +8536,7 @@
                 </a:solidFill>
                 <a:latin typeface="Helvetica Neue"/>
               </a:rPr>
-              <a:t>NOVELTY</a:t>
+              <a:t>THE METHOD</a:t>
             </a:r>
           </a:p>
         </p:txBody>
@@ -8720,7 +8578,7 @@
                 </a:solidFill>
                 <a:latin typeface="Helvetica Neue"/>
               </a:rPr>
-              <a:t>Novelty 1 — the physics-residual hybrid</a:t>
+              <a:t>PADR — phenology-aligned differentiable response</a:t>
             </a:r>
           </a:p>
         </p:txBody>
@@ -8759,7 +8617,7 @@
               </a:spcAft>
             </a:pPr>
             <a:r>
-              <a:rPr sz="1550" b="1" i="0">
+              <a:rPr sz="1700" b="1" i="0">
                 <a:solidFill>
                   <a:srgbClr val="EB6834"/>
                 </a:solidFill>
@@ -8768,22 +8626,22 @@
               <a:t>▸  </a:t>
             </a:r>
             <a:r>
-              <a:rPr sz="1550" b="1" i="0">
+              <a:rPr sz="1700" b="1" i="0">
                 <a:solidFill>
                   <a:srgbClr val="0B0B0B"/>
                 </a:solidFill>
                 <a:latin typeface="Helvetica Neue"/>
               </a:rPr>
-              <a:t>The problem  </a:t>
-            </a:r>
-            <a:r>
-              <a:rPr sz="1550" b="0" i="0">
+              <a:t>The shape  </a:t>
+            </a:r>
+            <a:r>
+              <a:rPr sz="1700" b="0" i="0">
                 <a:solidFill>
                   <a:srgbClr val="52514E"/>
                 </a:solidFill>
                 <a:latin typeface="Helvetica Neue"/>
               </a:rPr>
-              <a:t>with 28 records, every relationship learned from data spends statistical budget we do not have</a:t>
+              <a:t>yield = attainable yield × ∫ β(τ) · f_temp · f_water · f_waterlog dτ</a:t>
             </a:r>
           </a:p>
           <a:p>
@@ -8792,14 +8650,14 @@
                 <a:spcPct val="122000"/>
               </a:lnSpc>
               <a:spcBef>
-                <a:spcPts val="800"/>
+                <a:spcPts val="1100"/>
               </a:spcBef>
               <a:spcAft>
                 <a:spcPts val="200"/>
               </a:spcAft>
             </a:pPr>
             <a:r>
-              <a:rPr sz="1550" b="1" i="0">
+              <a:rPr sz="1700" b="1" i="0">
                 <a:solidFill>
                   <a:srgbClr val="EB6834"/>
                 </a:solidFill>
@@ -8808,22 +8666,22 @@
               <a:t>▸  </a:t>
             </a:r>
             <a:r>
-              <a:rPr sz="1550" b="1" i="0">
+              <a:rPr sz="1700" b="1" i="0">
                 <a:solidFill>
                   <a:srgbClr val="0B0B0B"/>
                 </a:solidFill>
                 <a:latin typeface="Helvetica Neue"/>
               </a:rPr>
-              <a:t>The idea  </a:t>
-            </a:r>
-            <a:r>
-              <a:rPr sz="1550" b="0" i="0">
+              <a:t>What is new  </a:t>
+            </a:r>
+            <a:r>
+              <a:rPr sz="1700" b="0" i="0">
                 <a:solidFill>
                   <a:srgbClr val="52514E"/>
                 </a:solidFill>
                 <a:latin typeface="Helvetica Neue"/>
               </a:rPr>
-              <a:t>supply the agronomy instead of learning it, and let the model learn only what the physics cannot explain</a:t>
+              <a:t>the FAO-33 and thermal constants are ESTIMATED, not fixed — existing hybrids freeze the crop model and fit ML on its residual</a:t>
             </a:r>
           </a:p>
           <a:p>
@@ -8832,14 +8690,14 @@
                 <a:spcPct val="122000"/>
               </a:lnSpc>
               <a:spcBef>
-                <a:spcPts val="800"/>
+                <a:spcPts val="1100"/>
               </a:spcBef>
               <a:spcAft>
                 <a:spcPts val="200"/>
               </a:spcAft>
             </a:pPr>
             <a:r>
-              <a:rPr sz="1550" b="1" i="0">
+              <a:rPr sz="1700" b="1" i="0">
                 <a:solidFill>
                   <a:srgbClr val="EB6834"/>
                 </a:solidFill>
@@ -8848,22 +8706,22 @@
               <a:t>▸  </a:t>
             </a:r>
             <a:r>
-              <a:rPr sz="1550" b="1" i="0">
+              <a:rPr sz="1700" b="1" i="0">
                 <a:solidFill>
                   <a:srgbClr val="0B0B0B"/>
                 </a:solidFill>
                 <a:latin typeface="Helvetica Neue"/>
               </a:rPr>
-              <a:t>Stage 1 — mechanistic backbone  </a:t>
-            </a:r>
-            <a:r>
-              <a:rPr sz="1550" b="0" i="0">
+              <a:t>Shrinkage to physics  </a:t>
+            </a:r>
+            <a:r>
+              <a:rPr sz="1700" b="0" i="0">
                 <a:solidFill>
                   <a:srgbClr val="52514E"/>
                 </a:solidFill>
                 <a:latin typeface="Helvetica Neue"/>
               </a:rPr>
-              <a:t>thermal time (growing degree days), water limitation (FAO-33, onion Ky ≈ 1.1), heat stress — multiplied into one suitability term</a:t>
+              <a:t>each constant is penalised toward its textbook value, so it moves only when the data pay for the move</a:t>
             </a:r>
           </a:p>
           <a:p>
@@ -8872,14 +8730,14 @@
                 <a:spcPct val="122000"/>
               </a:lnSpc>
               <a:spcBef>
-                <a:spcPts val="800"/>
+                <a:spcPts val="1100"/>
               </a:spcBef>
               <a:spcAft>
                 <a:spcPts val="200"/>
               </a:spcAft>
             </a:pPr>
             <a:r>
-              <a:rPr sz="1550" b="1" i="0">
+              <a:rPr sz="1700" b="1" i="0">
                 <a:solidFill>
                   <a:srgbClr val="EB6834"/>
                 </a:solidFill>
@@ -8888,22 +8746,22 @@
               <a:t>▸  </a:t>
             </a:r>
             <a:r>
-              <a:rPr sz="1550" b="1" i="0">
+              <a:rPr sz="1700" b="1" i="0">
                 <a:solidFill>
                   <a:srgbClr val="0B0B0B"/>
                 </a:solidFill>
                 <a:latin typeface="Helvetica Neue"/>
               </a:rPr>
-              <a:t>Calibration  </a:t>
-            </a:r>
-            <a:r>
-              <a:rPr sz="1550" b="0" i="0">
+              <a:t>Seventeen parameters  </a:t>
+            </a:r>
+            <a:r>
+              <a:rPr sz="1700" b="0" i="0">
                 <a:solidFill>
                   <a:srgbClr val="52514E"/>
                 </a:solidFill>
                 <a:latin typeface="Helvetica Neue"/>
               </a:rPr>
-              <a:t>only two parameters — an intercept and a slope — are fitted, and they are refitted inside every cross-validation fold</a:t>
+              <a:t>against 44,929 in the CNN-LSTM it replaces — a model this small is the only kind 24 training rows can support</a:t>
             </a:r>
           </a:p>
           <a:p>
@@ -8912,14 +8770,14 @@
                 <a:spcPct val="122000"/>
               </a:lnSpc>
               <a:spcBef>
-                <a:spcPts val="800"/>
+                <a:spcPts val="1100"/>
               </a:spcBef>
               <a:spcAft>
                 <a:spcPts val="200"/>
               </a:spcAft>
             </a:pPr>
             <a:r>
-              <a:rPr sz="1550" b="1" i="0">
+              <a:rPr sz="1700" b="1" i="0">
                 <a:solidFill>
                   <a:srgbClr val="EB6834"/>
                 </a:solidFill>
@@ -8928,22 +8786,22 @@
               <a:t>▸  </a:t>
             </a:r>
             <a:r>
-              <a:rPr sz="1550" b="1" i="0">
+              <a:rPr sz="1700" b="1" i="0">
                 <a:solidFill>
                   <a:srgbClr val="0B0B0B"/>
                 </a:solidFill>
                 <a:latin typeface="Helvetica Neue"/>
               </a:rPr>
-              <a:t>Stage 2 — learned residual  </a:t>
-            </a:r>
-            <a:r>
-              <a:rPr sz="1550" b="0" i="0">
+              <a:t>Fitted by L-BFGS-B  </a:t>
+            </a:r>
+            <a:r>
+              <a:rPr sz="1700" b="0" i="0">
                 <a:solidFill>
                   <a:srgbClr val="52514E"/>
                 </a:solidFill>
                 <a:latin typeface="Helvetica Neue"/>
               </a:rPr>
-              <a:t>a Random Forest on the difference between observed yield and the calibrated backbone</a:t>
+              <a:t>multi-start, agronomic box bounds, refit from scratch inside every fold</a:t>
             </a:r>
           </a:p>
         </p:txBody>
@@ -9073,7 +8931,7 @@
                 </a:solidFill>
                 <a:latin typeface="Helvetica Neue"/>
               </a:rPr>
-              <a:t>A prior that is only approximately right is worth more than the degrees of freedom it saves.</a:t>
+              <a:t>The fitted constants are the scientific output. They survive even when the prediction does not.</a:t>
             </a:r>
           </a:p>
         </p:txBody>
@@ -9185,7 +9043,7 @@
                 </a:solidFill>
                 <a:latin typeface="Helvetica Neue"/>
               </a:rPr>
-              <a:t>NOVELTY</a:t>
+              <a:t>THE METHOD</a:t>
             </a:r>
           </a:p>
         </p:txBody>
@@ -9227,45 +9085,21 @@
                 </a:solidFill>
                 <a:latin typeface="Helvetica Neue"/>
               </a:rPr>
-              <a:t>Novelty 2 — season-aware hybrid CNN-LSTM</a:t>
-            </a:r>
-          </a:p>
-        </p:txBody>
-      </p:sp>
-      <p:pic>
-        <p:nvPicPr>
-          <p:cNvPr id="5" name="Picture 4" descr="figure_5_2_cnn_lstm_hybrid.png"/>
-          <p:cNvPicPr>
-            <a:picLocks noChangeAspect="1"/>
-          </p:cNvPicPr>
-          <p:nvPr/>
-        </p:nvPicPr>
-        <p:blipFill>
-          <a:blip r:embed="rId2"/>
-          <a:stretch>
-            <a:fillRect/>
-          </a:stretch>
-        </p:blipFill>
-        <p:spPr>
-          <a:xfrm>
-            <a:off x="3413606" y="1783080"/>
-            <a:ext cx="5364483" cy="3977639"/>
-          </a:xfrm>
-          <a:prstGeom prst="rect">
-            <a:avLst/>
-          </a:prstGeom>
-        </p:spPr>
-      </p:pic>
-      <p:sp>
-        <p:nvSpPr>
-          <p:cNvPr id="6" name="TextBox 5"/>
+              <a:t>Weather on a thermal clock, not a calendar</a:t>
+            </a:r>
+          </a:p>
+        </p:txBody>
+      </p:sp>
+      <p:sp>
+        <p:nvSpPr>
+          <p:cNvPr id="5" name="TextBox 4"/>
           <p:cNvSpPr txBox="1"/>
           <p:nvPr/>
         </p:nvSpPr>
         <p:spPr>
           <a:xfrm>
-            <a:off x="777240" y="5907023"/>
-            <a:ext cx="10637215" cy="457200"/>
+            <a:off x="777240" y="1691640"/>
+            <a:ext cx="10637215" cy="4617720"/>
           </a:xfrm>
           <a:prstGeom prst="rect">
             <a:avLst/>
@@ -9279,21 +9113,202 @@
           <a:lstStyle/>
           <a:p>
             <a:pPr algn="l">
+              <a:lnSpc>
+                <a:spcPct val="122000"/>
+              </a:lnSpc>
               <a:spcBef>
                 <a:spcPts val="0"/>
               </a:spcBef>
               <a:spcAft>
-                <a:spcPts val="600"/>
+                <a:spcPts val="200"/>
               </a:spcAft>
             </a:pPr>
             <a:r>
-              <a:rPr sz="1300" b="0" i="0">
-                <a:solidFill>
-                  <a:srgbClr val="8A8983"/>
-                </a:solidFill>
-                <a:latin typeface="Helvetica Neue"/>
-              </a:rPr>
-              <a:t>The season indicator is concatenated AFTER both branches finish feature extraction — so the branches share parameters across seasons and only the small dense head learns season-specific baselines.</a:t>
+              <a:rPr sz="1700" b="1" i="0">
+                <a:solidFill>
+                  <a:srgbClr val="EB6834"/>
+                </a:solidFill>
+                <a:latin typeface="Helvetica Neue"/>
+              </a:rPr>
+              <a:t>▸  </a:t>
+            </a:r>
+            <a:r>
+              <a:rPr sz="1700" b="1" i="0">
+                <a:solidFill>
+                  <a:srgbClr val="0B0B0B"/>
+                </a:solidFill>
+                <a:latin typeface="Helvetica Neue"/>
+              </a:rPr>
+              <a:t>The problem  </a:t>
+            </a:r>
+            <a:r>
+              <a:rPr sz="1700" b="0" i="0">
+                <a:solidFill>
+                  <a:srgbClr val="52514E"/>
+                </a:solidFill>
+                <a:latin typeface="Helvetica Neue"/>
+              </a:rPr>
+              <a:t>'September rainfall' means a different developmental moment in each district-year</a:t>
+            </a:r>
+          </a:p>
+          <a:p>
+            <a:pPr algn="l">
+              <a:lnSpc>
+                <a:spcPct val="122000"/>
+              </a:lnSpc>
+              <a:spcBef>
+                <a:spcPts val="1100"/>
+              </a:spcBef>
+              <a:spcAft>
+                <a:spcPts val="200"/>
+              </a:spcAft>
+            </a:pPr>
+            <a:r>
+              <a:rPr sz="1700" b="1" i="0">
+                <a:solidFill>
+                  <a:srgbClr val="EB6834"/>
+                </a:solidFill>
+                <a:latin typeface="Helvetica Neue"/>
+              </a:rPr>
+              <a:t>▸  </a:t>
+            </a:r>
+            <a:r>
+              <a:rPr sz="1700" b="1" i="0">
+                <a:solidFill>
+                  <a:srgbClr val="0B0B0B"/>
+                </a:solidFill>
+                <a:latin typeface="Helvetica Neue"/>
+              </a:rPr>
+              <a:t>Satellite could not solve it  </a:t>
+            </a:r>
+            <a:r>
+              <a:rPr sz="1700" b="0" i="0">
+                <a:solidFill>
+                  <a:srgbClr val="52514E"/>
+                </a:solidFill>
+                <a:latin typeface="Helvetica Neue"/>
+              </a:rPr>
+              <a:t>onion is 0.002–0.89% of any district's land area, so district-mean NDVI measures paddy and scrub — 25 of 28 district-years failed to anchor</a:t>
+            </a:r>
+          </a:p>
+          <a:p>
+            <a:pPr algn="l">
+              <a:lnSpc>
+                <a:spcPct val="122000"/>
+              </a:lnSpc>
+              <a:spcBef>
+                <a:spcPts val="1100"/>
+              </a:spcBef>
+              <a:spcAft>
+                <a:spcPts val="200"/>
+              </a:spcAft>
+            </a:pPr>
+            <a:r>
+              <a:rPr sz="1700" b="1" i="0">
+                <a:solidFill>
+                  <a:srgbClr val="EB6834"/>
+                </a:solidFill>
+                <a:latin typeface="Helvetica Neue"/>
+              </a:rPr>
+              <a:t>▸  </a:t>
+            </a:r>
+            <a:r>
+              <a:rPr sz="1700" b="1" i="0">
+                <a:solidFill>
+                  <a:srgbClr val="0B0B0B"/>
+                </a:solidFill>
+                <a:latin typeface="Helvetica Neue"/>
+              </a:rPr>
+              <a:t>What worked instead  </a:t>
+            </a:r>
+            <a:r>
+              <a:rPr sz="1700" b="0" i="0">
+                <a:solidFill>
+                  <a:srgbClr val="52514E"/>
+                </a:solidFill>
+                <a:latin typeface="Helvetica Neue"/>
+              </a:rPr>
+              <a:t>harvest date from the DCS monthly production distribution — genuinely crop-specific, and it moves across 51 days</a:t>
+            </a:r>
+          </a:p>
+          <a:p>
+            <a:pPr algn="l">
+              <a:lnSpc>
+                <a:spcPct val="122000"/>
+              </a:lnSpc>
+              <a:spcBef>
+                <a:spcPts val="1100"/>
+              </a:spcBef>
+              <a:spcAft>
+                <a:spcPts val="200"/>
+              </a:spcAft>
+            </a:pPr>
+            <a:r>
+              <a:rPr sz="1700" b="1" i="0">
+                <a:solidFill>
+                  <a:srgbClr val="EB6834"/>
+                </a:solidFill>
+                <a:latin typeface="Helvetica Neue"/>
+              </a:rPr>
+              <a:t>▸  </a:t>
+            </a:r>
+            <a:r>
+              <a:rPr sz="1700" b="1" i="0">
+                <a:solidFill>
+                  <a:srgbClr val="0B0B0B"/>
+                </a:solidFill>
+                <a:latin typeface="Helvetica Neue"/>
+              </a:rPr>
+              <a:t>Thermal time backwards  </a:t>
+            </a:r>
+            <a:r>
+              <a:rPr sz="1700" b="0" i="0">
+                <a:solidFill>
+                  <a:srgbClr val="52514E"/>
+                </a:solidFill>
+                <a:latin typeface="Helvetica Neue"/>
+              </a:rPr>
+              <a:t>planting located by accumulating degree-days back from harvest; 28 of 28 anchored, zero fallbacks</a:t>
+            </a:r>
+          </a:p>
+          <a:p>
+            <a:pPr algn="l">
+              <a:lnSpc>
+                <a:spcPct val="122000"/>
+              </a:lnSpc>
+              <a:spcBef>
+                <a:spcPts val="1100"/>
+              </a:spcBef>
+              <a:spcAft>
+                <a:spcPts val="200"/>
+              </a:spcAft>
+            </a:pPr>
+            <a:r>
+              <a:rPr sz="1700" b="1" i="0">
+                <a:solidFill>
+                  <a:srgbClr val="EB6834"/>
+                </a:solidFill>
+                <a:latin typeface="Helvetica Neue"/>
+              </a:rPr>
+              <a:t>▸  </a:t>
+            </a:r>
+            <a:r>
+              <a:rPr sz="1700" b="1" i="0">
+                <a:solidFill>
+                  <a:srgbClr val="0B0B0B"/>
+                </a:solidFill>
+                <a:latin typeface="Helvetica Neue"/>
+              </a:rPr>
+              <a:t>It behaves like physics  </a:t>
+            </a:r>
+            <a:r>
+              <a:rPr sz="1700" b="0" i="0">
+                <a:solidFill>
+                  <a:srgbClr val="52514E"/>
+                </a:solidFill>
+                <a:latin typeface="Helvetica Neue"/>
+              </a:rPr>
+              <a:t>hot Anuradhapura completes a season in 78–86 days; cooler Matale needs 90–99 for the same heat</a:t>
             </a:r>
           </a:p>
         </p:txBody>
@@ -9454,14 +9469,281 @@
       </p:sp>
       <p:sp>
         <p:nvSpPr>
-          <p:cNvPr id="5" name="Rectangle 4"/>
+          <p:cNvPr id="5" name="TextBox 4"/>
+          <p:cNvSpPr txBox="1"/>
+          <p:nvPr/>
+        </p:nvSpPr>
+        <p:spPr>
+          <a:xfrm>
+            <a:off x="777240" y="1691640"/>
+            <a:ext cx="10637215" cy="3749040"/>
+          </a:xfrm>
+          <a:prstGeom prst="rect">
+            <a:avLst/>
+          </a:prstGeom>
+          <a:noFill/>
+        </p:spPr>
+        <p:txBody>
+          <a:bodyPr wrap="square" anchor="t" lIns="0" rIns="0" tIns="0" bIns="0">
+            <a:spAutoFit/>
+          </a:bodyPr>
+          <a:lstStyle/>
+          <a:p>
+            <a:pPr algn="l">
+              <a:lnSpc>
+                <a:spcPct val="122000"/>
+              </a:lnSpc>
+              <a:spcBef>
+                <a:spcPts val="0"/>
+              </a:spcBef>
+              <a:spcAft>
+                <a:spcPts val="200"/>
+              </a:spcAft>
+            </a:pPr>
+            <a:r>
+              <a:rPr sz="1550" b="1" i="0">
+                <a:solidFill>
+                  <a:srgbClr val="EB6834"/>
+                </a:solidFill>
+                <a:latin typeface="Helvetica Neue"/>
+              </a:rPr>
+              <a:t>▸  </a:t>
+            </a:r>
+            <a:r>
+              <a:rPr sz="1550" b="1" i="0">
+                <a:solidFill>
+                  <a:srgbClr val="0B0B0B"/>
+                </a:solidFill>
+                <a:latin typeface="Helvetica Neue"/>
+              </a:rPr>
+              <a:t>Leave-one-year-out  </a:t>
+            </a:r>
+            <a:r>
+              <a:rPr sz="1550" b="0" i="0">
+                <a:solidFill>
+                  <a:srgbClr val="52514E"/>
+                </a:solidFill>
+                <a:latin typeface="Helvetica Neue"/>
+              </a:rPr>
+              <a:t>hold out a whole year; every fitted quantity, including all scaling, estimated inside the fold</a:t>
+            </a:r>
+          </a:p>
+          <a:p>
+            <a:pPr algn="l">
+              <a:lnSpc>
+                <a:spcPct val="122000"/>
+              </a:lnSpc>
+              <a:spcBef>
+                <a:spcPts val="800"/>
+              </a:spcBef>
+              <a:spcAft>
+                <a:spcPts val="200"/>
+              </a:spcAft>
+            </a:pPr>
+            <a:r>
+              <a:rPr sz="1550" b="1" i="0">
+                <a:solidFill>
+                  <a:srgbClr val="EB6834"/>
+                </a:solidFill>
+                <a:latin typeface="Helvetica Neue"/>
+              </a:rPr>
+              <a:t>▸  </a:t>
+            </a:r>
+            <a:r>
+              <a:rPr sz="1550" b="1" i="0">
+                <a:solidFill>
+                  <a:srgbClr val="0B0B0B"/>
+                </a:solidFill>
+                <a:latin typeface="Helvetica Neue"/>
+              </a:rPr>
+              <a:t>Why not a random split  </a:t>
+            </a:r>
+            <a:r>
+              <a:rPr sz="1550" b="0" i="0">
+                <a:solidFill>
+                  <a:srgbClr val="52514E"/>
+                </a:solidFill>
+                <a:latin typeface="Helvetica Neue"/>
+              </a:rPr>
+              <a:t>records from one year share a weather regime; a random split would report a far more flattering and entirely misleading number</a:t>
+            </a:r>
+          </a:p>
+          <a:p>
+            <a:pPr algn="l">
+              <a:lnSpc>
+                <a:spcPct val="122000"/>
+              </a:lnSpc>
+              <a:spcBef>
+                <a:spcPts val="800"/>
+              </a:spcBef>
+              <a:spcAft>
+                <a:spcPts val="200"/>
+              </a:spcAft>
+            </a:pPr>
+            <a:r>
+              <a:rPr sz="1550" b="1" i="0">
+                <a:solidFill>
+                  <a:srgbClr val="EB6834"/>
+                </a:solidFill>
+                <a:latin typeface="Helvetica Neue"/>
+              </a:rPr>
+              <a:t>▸  </a:t>
+            </a:r>
+            <a:r>
+              <a:rPr sz="1550" b="1" i="0">
+                <a:solidFill>
+                  <a:srgbClr val="0B0B0B"/>
+                </a:solidFill>
+                <a:latin typeface="Helvetica Neue"/>
+              </a:rPr>
+              <a:t>Four leaks found and removed  </a:t>
+            </a:r>
+            <a:r>
+              <a:rPr sz="1550" b="0" i="0">
+                <a:solidFill>
+                  <a:srgbClr val="52514E"/>
+                </a:solidFill>
+                <a:latin typeface="Helvetica Neue"/>
+              </a:rPr>
+              <a:t>anomalies had been standardised on the full panel; the target had been winsorised at full-sample percentiles</a:t>
+            </a:r>
+          </a:p>
+          <a:p>
+            <a:pPr algn="l">
+              <a:lnSpc>
+                <a:spcPct val="122000"/>
+              </a:lnSpc>
+              <a:spcBef>
+                <a:spcPts val="800"/>
+              </a:spcBef>
+              <a:spcAft>
+                <a:spcPts val="200"/>
+              </a:spcAft>
+            </a:pPr>
+            <a:r>
+              <a:rPr sz="1550" b="1" i="0">
+                <a:solidFill>
+                  <a:srgbClr val="EB6834"/>
+                </a:solidFill>
+                <a:latin typeface="Helvetica Neue"/>
+              </a:rPr>
+              <a:t>▸  </a:t>
+            </a:r>
+            <a:r>
+              <a:rPr sz="1550" b="1" i="0">
+                <a:solidFill>
+                  <a:srgbClr val="0B0B0B"/>
+                </a:solidFill>
+                <a:latin typeface="Helvetica Neue"/>
+              </a:rPr>
+              <a:t>Yield lags dropped, not repaired  </a:t>
+            </a:r>
+            <a:r>
+              <a:rPr sz="1550" b="0" i="0">
+                <a:solidFill>
+                  <a:srgbClr val="52514E"/>
+                </a:solidFill>
+                <a:latin typeface="Helvetica Neue"/>
+              </a:rPr>
+              <a:t>under LOYO the row for year k+1 carries year k's observed yield — no clean fix inside this protocol</a:t>
+            </a:r>
+          </a:p>
+          <a:p>
+            <a:pPr algn="l">
+              <a:lnSpc>
+                <a:spcPct val="122000"/>
+              </a:lnSpc>
+              <a:spcBef>
+                <a:spcPts val="800"/>
+              </a:spcBef>
+              <a:spcAft>
+                <a:spcPts val="200"/>
+              </a:spcAft>
+            </a:pPr>
+            <a:r>
+              <a:rPr sz="1550" b="1" i="0">
+                <a:solidFill>
+                  <a:srgbClr val="EB6834"/>
+                </a:solidFill>
+                <a:latin typeface="Helvetica Neue"/>
+              </a:rPr>
+              <a:t>▸  </a:t>
+            </a:r>
+            <a:r>
+              <a:rPr sz="1550" b="1" i="0">
+                <a:solidFill>
+                  <a:srgbClr val="0B0B0B"/>
+                </a:solidFill>
+                <a:latin typeface="Helvetica Neue"/>
+              </a:rPr>
+              <a:t>Observations weighted by area  </a:t>
+            </a:r>
+            <a:r>
+              <a:rPr sz="1550" b="0" i="0">
+                <a:solidFill>
+                  <a:srgbClr val="52514E"/>
+                </a:solidFill>
+                <a:latin typeface="Helvetica Neue"/>
+              </a:rPr>
+              <a:t>cells span 3.5 to 1,765 hectares; treating them as equally reliable is not defensible</a:t>
+            </a:r>
+          </a:p>
+        </p:txBody>
+      </p:sp>
+      <p:sp>
+        <p:nvSpPr>
+          <p:cNvPr id="6" name="Rectangle 5"/>
           <p:cNvSpPr/>
           <p:nvPr/>
         </p:nvSpPr>
         <p:spPr>
           <a:xfrm>
-            <a:off x="777240" y="1691640"/>
-            <a:ext cx="45720" cy="292608"/>
+            <a:off x="777240" y="5623560"/>
+            <a:ext cx="10637215" cy="731520"/>
+          </a:xfrm>
+          <a:prstGeom prst="rect">
+            <a:avLst/>
+          </a:prstGeom>
+          <a:solidFill>
+            <a:srgbClr val="F2F1EE"/>
+          </a:solidFill>
+          <a:ln>
+            <a:noFill/>
+          </a:ln>
+          <a:effectLst/>
+        </p:spPr>
+        <p:style>
+          <a:lnRef idx="1">
+            <a:schemeClr val="accent1"/>
+          </a:lnRef>
+          <a:fillRef idx="3">
+            <a:schemeClr val="accent1"/>
+          </a:fillRef>
+          <a:effectRef idx="2">
+            <a:schemeClr val="accent1"/>
+          </a:effectRef>
+          <a:fontRef idx="minor">
+            <a:schemeClr val="lt1"/>
+          </a:fontRef>
+        </p:style>
+        <p:txBody>
+          <a:bodyPr rtlCol="0" anchor="ctr"/>
+          <a:lstStyle/>
+          <a:p>
+            <a:pPr algn="ctr"/>
+          </a:p>
+        </p:txBody>
+      </p:sp>
+      <p:sp>
+        <p:nvSpPr>
+          <p:cNvPr id="7" name="Rectangle 6"/>
+          <p:cNvSpPr/>
+          <p:nvPr/>
+        </p:nvSpPr>
+        <p:spPr>
+          <a:xfrm>
+            <a:off x="777240" y="5623560"/>
+            <a:ext cx="54864" cy="731520"/>
           </a:xfrm>
           <a:prstGeom prst="rect">
             <a:avLst/>
@@ -9498,14 +9780,14 @@
       </p:sp>
       <p:sp>
         <p:nvSpPr>
-          <p:cNvPr id="6" name="TextBox 5"/>
+          <p:cNvPr id="8" name="TextBox 7"/>
           <p:cNvSpPr txBox="1"/>
           <p:nvPr/>
         </p:nvSpPr>
         <p:spPr>
           <a:xfrm>
-            <a:off x="960120" y="1691640"/>
-            <a:ext cx="4884267" cy="320040"/>
+            <a:off x="1051560" y="5623560"/>
+            <a:ext cx="10088575" cy="731520"/>
           </a:xfrm>
           <a:prstGeom prst="rect">
             <a:avLst/>
@@ -9513,7 +9795,7 @@
           <a:noFill/>
         </p:spPr>
         <p:txBody>
-          <a:bodyPr wrap="square" anchor="t" lIns="0" rIns="0" tIns="0" bIns="0">
+          <a:bodyPr wrap="square" anchor="ctr" lIns="0" rIns="0" tIns="0" bIns="0">
             <a:spAutoFit/>
           </a:bodyPr>
           <a:lstStyle/>
@@ -9527,585 +9809,13 @@
               </a:spcAft>
             </a:pPr>
             <a:r>
-              <a:rPr sz="1700" b="1" i="0">
+              <a:rPr sz="1500" b="1" i="0">
                 <a:solidFill>
                   <a:srgbClr val="0D366B"/>
                 </a:solidFill>
                 <a:latin typeface="Helvetica Neue"/>
               </a:rPr>
-              <a:t>What most papers do</a:t>
-            </a:r>
-          </a:p>
-        </p:txBody>
-      </p:sp>
-      <p:sp>
-        <p:nvSpPr>
-          <p:cNvPr id="7" name="TextBox 6"/>
-          <p:cNvSpPr txBox="1"/>
-          <p:nvPr/>
-        </p:nvSpPr>
-        <p:spPr>
-          <a:xfrm>
-            <a:off x="777240" y="2194560"/>
-            <a:ext cx="5067147" cy="3200400"/>
-          </a:xfrm>
-          <a:prstGeom prst="rect">
-            <a:avLst/>
-          </a:prstGeom>
-          <a:noFill/>
-        </p:spPr>
-        <p:txBody>
-          <a:bodyPr wrap="square" anchor="t" lIns="0" rIns="0" tIns="0" bIns="0">
-            <a:spAutoFit/>
-          </a:bodyPr>
-          <a:lstStyle/>
-          <a:p>
-            <a:pPr algn="l">
-              <a:lnSpc>
-                <a:spcPct val="120000"/>
-              </a:lnSpc>
-              <a:spcBef>
-                <a:spcPts val="0"/>
-              </a:spcBef>
-              <a:spcAft>
-                <a:spcPts val="200"/>
-              </a:spcAft>
-            </a:pPr>
-            <a:r>
-              <a:rPr sz="1500" b="1" i="0">
-                <a:solidFill>
-                  <a:srgbClr val="EB6834"/>
-                </a:solidFill>
-                <a:latin typeface="Helvetica Neue"/>
-              </a:rPr>
-              <a:t>•  </a:t>
-            </a:r>
-            <a:r>
-              <a:rPr sz="1500" b="0" i="0">
-                <a:solidFill>
-                  <a:srgbClr val="52514E"/>
-                </a:solidFill>
-                <a:latin typeface="Helvetica Neue"/>
-              </a:rPr>
-              <a:t>Split records at random into train and test</a:t>
-            </a:r>
-          </a:p>
-          <a:p>
-            <a:pPr algn="l">
-              <a:lnSpc>
-                <a:spcPct val="120000"/>
-              </a:lnSpc>
-              <a:spcBef>
-                <a:spcPts val="900"/>
-              </a:spcBef>
-              <a:spcAft>
-                <a:spcPts val="200"/>
-              </a:spcAft>
-            </a:pPr>
-            <a:r>
-              <a:rPr sz="1500" b="1" i="0">
-                <a:solidFill>
-                  <a:srgbClr val="EB6834"/>
-                </a:solidFill>
-                <a:latin typeface="Helvetica Neue"/>
-              </a:rPr>
-              <a:t>•  </a:t>
-            </a:r>
-            <a:r>
-              <a:rPr sz="1500" b="0" i="0">
-                <a:solidFill>
-                  <a:srgbClr val="52514E"/>
-                </a:solidFill>
-                <a:latin typeface="Helvetica Neue"/>
-              </a:rPr>
-              <a:t>Districts from the same year land on both sides</a:t>
-            </a:r>
-          </a:p>
-          <a:p>
-            <a:pPr algn="l">
-              <a:lnSpc>
-                <a:spcPct val="120000"/>
-              </a:lnSpc>
-              <a:spcBef>
-                <a:spcPts val="900"/>
-              </a:spcBef>
-              <a:spcAft>
-                <a:spcPts val="200"/>
-              </a:spcAft>
-            </a:pPr>
-            <a:r>
-              <a:rPr sz="1500" b="1" i="0">
-                <a:solidFill>
-                  <a:srgbClr val="EB6834"/>
-                </a:solidFill>
-                <a:latin typeface="Helvetica Neue"/>
-              </a:rPr>
-              <a:t>•  </a:t>
-            </a:r>
-            <a:r>
-              <a:rPr sz="1500" b="0" i="0">
-                <a:solidFill>
-                  <a:srgbClr val="52514E"/>
-                </a:solidFill>
-                <a:latin typeface="Helvetica Neue"/>
-              </a:rPr>
-              <a:t>They share a weather regime and a monsoon anomaly</a:t>
-            </a:r>
-          </a:p>
-          <a:p>
-            <a:pPr algn="l">
-              <a:lnSpc>
-                <a:spcPct val="120000"/>
-              </a:lnSpc>
-              <a:spcBef>
-                <a:spcPts val="900"/>
-              </a:spcBef>
-              <a:spcAft>
-                <a:spcPts val="200"/>
-              </a:spcAft>
-            </a:pPr>
-            <a:r>
-              <a:rPr sz="1500" b="1" i="0">
-                <a:solidFill>
-                  <a:srgbClr val="EB6834"/>
-                </a:solidFill>
-                <a:latin typeface="Helvetica Neue"/>
-              </a:rPr>
-              <a:t>•  </a:t>
-            </a:r>
-            <a:r>
-              <a:rPr sz="1500" b="0" i="0">
-                <a:solidFill>
-                  <a:srgbClr val="52514E"/>
-                </a:solidFill>
-                <a:latin typeface="Helvetica Neue"/>
-              </a:rPr>
-              <a:t>The model effectively sees the answer for the year it predicts</a:t>
-            </a:r>
-          </a:p>
-          <a:p>
-            <a:pPr algn="l">
-              <a:lnSpc>
-                <a:spcPct val="120000"/>
-              </a:lnSpc>
-              <a:spcBef>
-                <a:spcPts val="900"/>
-              </a:spcBef>
-              <a:spcAft>
-                <a:spcPts val="200"/>
-              </a:spcAft>
-            </a:pPr>
-            <a:r>
-              <a:rPr sz="1500" b="1" i="0">
-                <a:solidFill>
-                  <a:srgbClr val="EB6834"/>
-                </a:solidFill>
-                <a:latin typeface="Helvetica Neue"/>
-              </a:rPr>
-              <a:t>•  </a:t>
-            </a:r>
-            <a:r>
-              <a:rPr sz="1500" b="0" i="0">
-                <a:solidFill>
-                  <a:srgbClr val="52514E"/>
-                </a:solidFill>
-                <a:latin typeface="Helvetica Neue"/>
-              </a:rPr>
-              <a:t>Reported scores are optimistic and do not survive deployment</a:t>
-            </a:r>
-          </a:p>
-        </p:txBody>
-      </p:sp>
-      <p:sp>
-        <p:nvSpPr>
-          <p:cNvPr id="8" name="Rectangle 7"/>
-          <p:cNvSpPr/>
-          <p:nvPr/>
-        </p:nvSpPr>
-        <p:spPr>
-          <a:xfrm>
-            <a:off x="6347307" y="1691640"/>
-            <a:ext cx="45720" cy="292608"/>
-          </a:xfrm>
-          <a:prstGeom prst="rect">
-            <a:avLst/>
-          </a:prstGeom>
-          <a:solidFill>
-            <a:srgbClr val="2A78D6"/>
-          </a:solidFill>
-          <a:ln>
-            <a:noFill/>
-          </a:ln>
-          <a:effectLst/>
-        </p:spPr>
-        <p:style>
-          <a:lnRef idx="1">
-            <a:schemeClr val="accent1"/>
-          </a:lnRef>
-          <a:fillRef idx="3">
-            <a:schemeClr val="accent1"/>
-          </a:fillRef>
-          <a:effectRef idx="2">
-            <a:schemeClr val="accent1"/>
-          </a:effectRef>
-          <a:fontRef idx="minor">
-            <a:schemeClr val="lt1"/>
-          </a:fontRef>
-        </p:style>
-        <p:txBody>
-          <a:bodyPr rtlCol="0" anchor="ctr"/>
-          <a:lstStyle/>
-          <a:p>
-            <a:pPr algn="ctr"/>
-          </a:p>
-        </p:txBody>
-      </p:sp>
-      <p:sp>
-        <p:nvSpPr>
-          <p:cNvPr id="9" name="TextBox 8"/>
-          <p:cNvSpPr txBox="1"/>
-          <p:nvPr/>
-        </p:nvSpPr>
-        <p:spPr>
-          <a:xfrm>
-            <a:off x="6530187" y="1691640"/>
-            <a:ext cx="4884267" cy="320040"/>
-          </a:xfrm>
-          <a:prstGeom prst="rect">
-            <a:avLst/>
-          </a:prstGeom>
-          <a:noFill/>
-        </p:spPr>
-        <p:txBody>
-          <a:bodyPr wrap="square" anchor="t" lIns="0" rIns="0" tIns="0" bIns="0">
-            <a:spAutoFit/>
-          </a:bodyPr>
-          <a:lstStyle/>
-          <a:p>
-            <a:pPr algn="l">
-              <a:spcBef>
-                <a:spcPts val="0"/>
-              </a:spcBef>
-              <a:spcAft>
-                <a:spcPts val="600"/>
-              </a:spcAft>
-            </a:pPr>
-            <a:r>
-              <a:rPr sz="1700" b="1" i="0">
-                <a:solidFill>
-                  <a:srgbClr val="0D366B"/>
-                </a:solidFill>
-                <a:latin typeface="Helvetica Neue"/>
-              </a:rPr>
-              <a:t>What we do</a:t>
-            </a:r>
-          </a:p>
-        </p:txBody>
-      </p:sp>
-      <p:sp>
-        <p:nvSpPr>
-          <p:cNvPr id="10" name="TextBox 9"/>
-          <p:cNvSpPr txBox="1"/>
-          <p:nvPr/>
-        </p:nvSpPr>
-        <p:spPr>
-          <a:xfrm>
-            <a:off x="6347307" y="2194560"/>
-            <a:ext cx="5067147" cy="3200400"/>
-          </a:xfrm>
-          <a:prstGeom prst="rect">
-            <a:avLst/>
-          </a:prstGeom>
-          <a:noFill/>
-        </p:spPr>
-        <p:txBody>
-          <a:bodyPr wrap="square" anchor="t" lIns="0" rIns="0" tIns="0" bIns="0">
-            <a:spAutoFit/>
-          </a:bodyPr>
-          <a:lstStyle/>
-          <a:p>
-            <a:pPr algn="l">
-              <a:lnSpc>
-                <a:spcPct val="120000"/>
-              </a:lnSpc>
-              <a:spcBef>
-                <a:spcPts val="0"/>
-              </a:spcBef>
-              <a:spcAft>
-                <a:spcPts val="200"/>
-              </a:spcAft>
-            </a:pPr>
-            <a:r>
-              <a:rPr sz="1500" b="1" i="0">
-                <a:solidFill>
-                  <a:srgbClr val="2A78D6"/>
-                </a:solidFill>
-                <a:latin typeface="Helvetica Neue"/>
-              </a:rPr>
-              <a:t>•  </a:t>
-            </a:r>
-            <a:r>
-              <a:rPr sz="1500" b="0" i="0">
-                <a:solidFill>
-                  <a:srgbClr val="52514E"/>
-                </a:solidFill>
-                <a:latin typeface="Helvetica Neue"/>
-              </a:rPr>
-              <a:t>Leave-One-Year-Out: hold out an entire year, rotate through all seven</a:t>
-            </a:r>
-          </a:p>
-          <a:p>
-            <a:pPr algn="l">
-              <a:lnSpc>
-                <a:spcPct val="120000"/>
-              </a:lnSpc>
-              <a:spcBef>
-                <a:spcPts val="900"/>
-              </a:spcBef>
-              <a:spcAft>
-                <a:spcPts val="200"/>
-              </a:spcAft>
-            </a:pPr>
-            <a:r>
-              <a:rPr sz="1500" b="1" i="0">
-                <a:solidFill>
-                  <a:srgbClr val="2A78D6"/>
-                </a:solidFill>
-                <a:latin typeface="Helvetica Neue"/>
-              </a:rPr>
-              <a:t>•  </a:t>
-            </a:r>
-            <a:r>
-              <a:rPr sz="1500" b="0" i="0">
-                <a:solidFill>
-                  <a:srgbClr val="52514E"/>
-                </a:solidFill>
-                <a:latin typeface="Helvetica Neue"/>
-              </a:rPr>
-              <a:t>Hyperparameters chosen by an inner search inside the training partition only</a:t>
-            </a:r>
-          </a:p>
-          <a:p>
-            <a:pPr algn="l">
-              <a:lnSpc>
-                <a:spcPct val="120000"/>
-              </a:lnSpc>
-              <a:spcBef>
-                <a:spcPts val="900"/>
-              </a:spcBef>
-              <a:spcAft>
-                <a:spcPts val="200"/>
-              </a:spcAft>
-            </a:pPr>
-            <a:r>
-              <a:rPr sz="1500" b="1" i="0">
-                <a:solidFill>
-                  <a:srgbClr val="2A78D6"/>
-                </a:solidFill>
-                <a:latin typeface="Helvetica Neue"/>
-              </a:rPr>
-              <a:t>•  </a:t>
-            </a:r>
-            <a:r>
-              <a:rPr sz="1500" b="0" i="0">
-                <a:solidFill>
-                  <a:srgbClr val="52514E"/>
-                </a:solidFill>
-                <a:latin typeface="Helvetica Neue"/>
-              </a:rPr>
-              <a:t>Every fitted quantity — including the physics calibration — refitted per fold</a:t>
-            </a:r>
-          </a:p>
-          <a:p>
-            <a:pPr algn="l">
-              <a:lnSpc>
-                <a:spcPct val="120000"/>
-              </a:lnSpc>
-              <a:spcBef>
-                <a:spcPts val="900"/>
-              </a:spcBef>
-              <a:spcAft>
-                <a:spcPts val="200"/>
-              </a:spcAft>
-            </a:pPr>
-            <a:r>
-              <a:rPr sz="1500" b="1" i="0">
-                <a:solidFill>
-                  <a:srgbClr val="2A78D6"/>
-                </a:solidFill>
-                <a:latin typeface="Helvetica Neue"/>
-              </a:rPr>
-              <a:t>•  </a:t>
-            </a:r>
-            <a:r>
-              <a:rPr sz="1500" b="0" i="0">
-                <a:solidFill>
-                  <a:srgbClr val="52514E"/>
-                </a:solidFill>
-                <a:latin typeface="Helvetica Neue"/>
-              </a:rPr>
-              <a:t>Models compared with the paired Wilcoxon signed-rank test</a:t>
-            </a:r>
-          </a:p>
-          <a:p>
-            <a:pPr algn="l">
-              <a:lnSpc>
-                <a:spcPct val="120000"/>
-              </a:lnSpc>
-              <a:spcBef>
-                <a:spcPts val="900"/>
-              </a:spcBef>
-              <a:spcAft>
-                <a:spcPts val="200"/>
-              </a:spcAft>
-            </a:pPr>
-            <a:r>
-              <a:rPr sz="1500" b="1" i="0">
-                <a:solidFill>
-                  <a:srgbClr val="2A78D6"/>
-                </a:solidFill>
-                <a:latin typeface="Helvetica Neue"/>
-              </a:rPr>
-              <a:t>•  </a:t>
-            </a:r>
-            <a:r>
-              <a:rPr sz="1500" b="0" i="0">
-                <a:solidFill>
-                  <a:srgbClr val="52514E"/>
-                </a:solidFill>
-                <a:latin typeface="Helvetica Neue"/>
-              </a:rPr>
-              <a:t>Split-conformal prediction intervals attached to every forecast</a:t>
-            </a:r>
-          </a:p>
-        </p:txBody>
-      </p:sp>
-      <p:sp>
-        <p:nvSpPr>
-          <p:cNvPr id="11" name="Rectangle 10"/>
-          <p:cNvSpPr/>
-          <p:nvPr/>
-        </p:nvSpPr>
-        <p:spPr>
-          <a:xfrm>
-            <a:off x="777240" y="5623560"/>
-            <a:ext cx="10637215" cy="731520"/>
-          </a:xfrm>
-          <a:prstGeom prst="rect">
-            <a:avLst/>
-          </a:prstGeom>
-          <a:solidFill>
-            <a:srgbClr val="F2F1EE"/>
-          </a:solidFill>
-          <a:ln>
-            <a:noFill/>
-          </a:ln>
-          <a:effectLst/>
-        </p:spPr>
-        <p:style>
-          <a:lnRef idx="1">
-            <a:schemeClr val="accent1"/>
-          </a:lnRef>
-          <a:fillRef idx="3">
-            <a:schemeClr val="accent1"/>
-          </a:fillRef>
-          <a:effectRef idx="2">
-            <a:schemeClr val="accent1"/>
-          </a:effectRef>
-          <a:fontRef idx="minor">
-            <a:schemeClr val="lt1"/>
-          </a:fontRef>
-        </p:style>
-        <p:txBody>
-          <a:bodyPr rtlCol="0" anchor="ctr"/>
-          <a:lstStyle/>
-          <a:p>
-            <a:pPr algn="ctr"/>
-          </a:p>
-        </p:txBody>
-      </p:sp>
-      <p:sp>
-        <p:nvSpPr>
-          <p:cNvPr id="12" name="Rectangle 11"/>
-          <p:cNvSpPr/>
-          <p:nvPr/>
-        </p:nvSpPr>
-        <p:spPr>
-          <a:xfrm>
-            <a:off x="777240" y="5623560"/>
-            <a:ext cx="54864" cy="731520"/>
-          </a:xfrm>
-          <a:prstGeom prst="rect">
-            <a:avLst/>
-          </a:prstGeom>
-          <a:solidFill>
-            <a:srgbClr val="EB6834"/>
-          </a:solidFill>
-          <a:ln>
-            <a:noFill/>
-          </a:ln>
-          <a:effectLst/>
-        </p:spPr>
-        <p:style>
-          <a:lnRef idx="1">
-            <a:schemeClr val="accent1"/>
-          </a:lnRef>
-          <a:fillRef idx="3">
-            <a:schemeClr val="accent1"/>
-          </a:fillRef>
-          <a:effectRef idx="2">
-            <a:schemeClr val="accent1"/>
-          </a:effectRef>
-          <a:fontRef idx="minor">
-            <a:schemeClr val="lt1"/>
-          </a:fontRef>
-        </p:style>
-        <p:txBody>
-          <a:bodyPr rtlCol="0" anchor="ctr"/>
-          <a:lstStyle/>
-          <a:p>
-            <a:pPr algn="ctr"/>
-          </a:p>
-        </p:txBody>
-      </p:sp>
-      <p:sp>
-        <p:nvSpPr>
-          <p:cNvPr id="13" name="TextBox 12"/>
-          <p:cNvSpPr txBox="1"/>
-          <p:nvPr/>
-        </p:nvSpPr>
-        <p:spPr>
-          <a:xfrm>
-            <a:off x="1051560" y="5623560"/>
-            <a:ext cx="10088575" cy="731520"/>
-          </a:xfrm>
-          <a:prstGeom prst="rect">
-            <a:avLst/>
-          </a:prstGeom>
-          <a:noFill/>
-        </p:spPr>
-        <p:txBody>
-          <a:bodyPr wrap="square" anchor="ctr" lIns="0" rIns="0" tIns="0" bIns="0">
-            <a:spAutoFit/>
-          </a:bodyPr>
-          <a:lstStyle/>
-          <a:p>
-            <a:pPr algn="l">
-              <a:spcBef>
-                <a:spcPts val="0"/>
-              </a:spcBef>
-              <a:spcAft>
-                <a:spcPts val="600"/>
-              </a:spcAft>
-            </a:pPr>
-            <a:r>
-              <a:rPr sz="1500" b="1" i="0">
-                <a:solidFill>
-                  <a:srgbClr val="0D366B"/>
-                </a:solidFill>
-                <a:latin typeface="Helvetica Neue"/>
-              </a:rPr>
-              <a:t>A random split would have given us far better-looking numbers. It would also have been wrong.</a:t>
+              <a:t>An honest protocol is why our numbers are lower than published work using random splits.</a:t>
             </a:r>
           </a:p>
         </p:txBody>
@@ -10304,7 +10014,7 @@
                 </a:solidFill>
                 <a:latin typeface="Helvetica Neue"/>
               </a:rPr>
-              <a:t>Everything that follows is measured on the 28 seasonal records we actually collected. One slide, clearly labelled, uses synthetic data.</a:t>
+              <a:t>What we found when we audited our own data — and what the corrected panel can and cannot support.</a:t>
             </a:r>
           </a:p>
         </p:txBody>
@@ -10458,7 +10168,7 @@
                 </a:solidFill>
                 <a:latin typeface="Helvetica Neue"/>
               </a:rPr>
-              <a:t>What the data actually is</a:t>
+              <a:t>We audited our own dataset. It did not survive.</a:t>
             </a:r>
           </a:p>
         </p:txBody>
@@ -10522,7 +10232,7 @@
             <a:avLst/>
           </a:prstGeom>
           <a:solidFill>
-            <a:srgbClr val="4A3AA7"/>
+            <a:srgbClr val="EB6834"/>
           </a:solidFill>
           <a:ln>
             <a:noFill/>
@@ -10584,11 +10294,11 @@
             <a:r>
               <a:rPr sz="4800" b="1" i="0">
                 <a:solidFill>
-                  <a:srgbClr val="4A3AA7"/>
-                </a:solidFill>
-                <a:latin typeface="Helvetica Neue"/>
-              </a:rPr>
-              <a:t>28</a:t>
+                  <a:srgbClr val="EB6834"/>
+                </a:solidFill>
+                <a:latin typeface="Helvetica Neue"/>
+              </a:rPr>
+              <a:t>40%</a:t>
             </a:r>
           </a:p>
         </p:txBody>
@@ -10633,7 +10343,7 @@
                 </a:solidFill>
                 <a:latin typeface="Helvetica Neue"/>
               </a:rPr>
-              <a:t>seasonal records collected — 4 districts × 7 years</a:t>
+              <a:t>of the target variable was fabricated — 50 of 124 month-rows</a:t>
             </a:r>
           </a:p>
         </p:txBody>
@@ -10697,7 +10407,7 @@
             <a:avLst/>
           </a:prstGeom>
           <a:solidFill>
-            <a:srgbClr val="EB6834"/>
+            <a:srgbClr val="4A3AA7"/>
           </a:solidFill>
           <a:ln>
             <a:noFill/>
@@ -10759,11 +10469,11 @@
             <a:r>
               <a:rPr sz="4800" b="1" i="0">
                 <a:solidFill>
-                  <a:srgbClr val="EB6834"/>
-                </a:solidFill>
-                <a:latin typeface="Helvetica Neue"/>
-              </a:rPr>
-              <a:t>32</a:t>
+                  <a:srgbClr val="4A3AA7"/>
+                </a:solidFill>
+                <a:latin typeface="Helvetica Neue"/>
+              </a:rPr>
+              <a:t>442</a:t>
             </a:r>
           </a:p>
         </p:txBody>
@@ -10808,7 +10518,7 @@
                 </a:solidFill>
                 <a:latin typeface="Helvetica Neue"/>
               </a:rPr>
-              <a:t>candidate predictors — more features than observations</a:t>
+              <a:t>MT/ha implied by one record; onion's world record is ~100</a:t>
             </a:r>
           </a:p>
         </p:txBody>
@@ -10938,7 +10648,7 @@
                 </a:solidFill>
                 <a:latin typeface="Helvetica Neue"/>
               </a:rPr>
-              <a:t>1</a:t>
+              <a:t>0.68</a:t>
             </a:r>
           </a:p>
         </p:txBody>
@@ -10983,7 +10693,7 @@
                 </a:solidFill>
                 <a:latin typeface="Helvetica Neue"/>
               </a:rPr>
-              <a:t>season only — Yala; no Maha in the collected record</a:t>
+              <a:t>correlation between the old target and the corrected one</a:t>
             </a:r>
           </a:p>
         </p:txBody>
@@ -11028,7 +10738,7 @@
                 </a:solidFill>
                 <a:latin typeface="Helvetica Neue"/>
               </a:rPr>
-              <a:t>Anuradhapura, Kurunegala, Matale and Polonnaruwa, 2019–2025. Mean yield 16.39 MT/Ha (range 8.50–24.06). Each cross-validation fold trains on 24 records. Read every result that follows against this slide.</a:t>
+              <a:t>The fabrication reached the TARGET, not just the covariates: yield varies month to month within every cell and the target was their unweighted mean. Rebuilt from 87 genuine DCS records as total production over total harvested area.</a:t>
             </a:r>
           </a:p>
         </p:txBody>
@@ -11325,7 +11035,7 @@
                 </a:solidFill>
                 <a:latin typeface="Helvetica Neue"/>
               </a:rPr>
-              <a:t>multi-source data, 32 predictors, nine models, one honest protocol</a:t>
+              <a:t>multi-source data, real daily weather, one honest protocol</a:t>
             </a:r>
           </a:p>
           <a:p>
@@ -11356,7 +11066,7 @@
                 </a:solidFill>
                 <a:latin typeface="Helvetica Neue"/>
               </a:rPr>
-              <a:t>Two novelties  </a:t>
+              <a:t>The method  </a:t>
             </a:r>
             <a:r>
               <a:rPr sz="1550" b="0" i="0">
@@ -11365,7 +11075,7 @@
                 </a:solidFill>
                 <a:latin typeface="Helvetica Neue"/>
               </a:rPr>
-              <a:t>a physics-residual hybrid and a season-aware CNN-LSTM</a:t>
+              <a:t>PADR — an agronomic model whose crop constants are estimated, not assumed</a:t>
             </a:r>
           </a:p>
           <a:p>
@@ -11405,7 +11115,47 @@
                 </a:solidFill>
                 <a:latin typeface="Helvetica Neue"/>
               </a:rPr>
-              <a:t>what 28 real records actually support — including what failed</a:t>
+              <a:t>what we found when we audited our own data, and what 28 records support</a:t>
+            </a:r>
+          </a:p>
+          <a:p>
+            <a:pPr algn="l">
+              <a:lnSpc>
+                <a:spcPct val="122000"/>
+              </a:lnSpc>
+              <a:spcBef>
+                <a:spcPts val="800"/>
+              </a:spcBef>
+              <a:spcAft>
+                <a:spcPts val="200"/>
+              </a:spcAft>
+            </a:pPr>
+            <a:r>
+              <a:rPr sz="1550" b="1" i="0">
+                <a:solidFill>
+                  <a:srgbClr val="EB6834"/>
+                </a:solidFill>
+                <a:latin typeface="Helvetica Neue"/>
+              </a:rPr>
+              <a:t>▸  </a:t>
+            </a:r>
+            <a:r>
+              <a:rPr sz="1550" b="1" i="0">
+                <a:solidFill>
+                  <a:srgbClr val="0B0B0B"/>
+                </a:solidFill>
+                <a:latin typeface="Helvetica Neue"/>
+              </a:rPr>
+              <a:t>Two findings we withdraw  </a:t>
+            </a:r>
+            <a:r>
+              <a:rPr sz="1550" b="0" i="0">
+                <a:solidFill>
+                  <a:srgbClr val="52514E"/>
+                </a:solidFill>
+                <a:latin typeface="Helvetica Neue"/>
+              </a:rPr>
+              <a:t>and why reporting them is the point</a:t>
             </a:r>
           </a:p>
           <a:p>
@@ -11599,14 +11349,14 @@
                 </a:solidFill>
                 <a:latin typeface="Helvetica Neue"/>
               </a:rPr>
-              <a:t>Model comparison under Leave-One-Year-Out CV</a:t>
+              <a:t>The 0.75 target was not difficult. It was unattainable.</a:t>
             </a:r>
           </a:p>
         </p:txBody>
       </p:sp>
       <p:pic>
         <p:nvPicPr>
-          <p:cNvPr id="5" name="Picture 4" descr="model_comparison.png"/>
+          <p:cNvPr id="5" name="Picture 4" descr="variance_ceiling.png"/>
           <p:cNvPicPr>
             <a:picLocks noChangeAspect="1"/>
           </p:cNvPicPr>
@@ -11620,8 +11370,8 @@
         </p:blipFill>
         <p:spPr>
           <a:xfrm>
-            <a:off x="2039041" y="1783080"/>
-            <a:ext cx="8113613" cy="4343400"/>
+            <a:off x="777240" y="1783080"/>
+            <a:ext cx="10637215" cy="4037750"/>
           </a:xfrm>
           <a:prstGeom prst="rect">
             <a:avLst/>
@@ -11636,7 +11386,7 @@
         </p:nvSpPr>
         <p:spPr>
           <a:xfrm>
-            <a:off x="777240" y="6272784"/>
+            <a:off x="777240" y="5967134"/>
             <a:ext cx="10637215" cy="457200"/>
           </a:xfrm>
           <a:prstGeom prst="rect">
@@ -11665,7 +11415,7 @@
                 </a:solidFill>
                 <a:latin typeface="Helvetica Neue"/>
               </a:rPr>
-              <a:t>Physics-residual hybrid leads at RMSE 3.90 MT/Ha, R² 0.091. Every deep architecture falls below the mean predictor.</a:t>
+              <a:t>64% of variance lies between years and leave-one-year-out removes it by construction; measurement error is 54% of what remains within a year.</a:t>
             </a:r>
           </a:p>
         </p:txBody>
@@ -11819,21 +11569,45 @@
                 </a:solidFill>
                 <a:latin typeface="Helvetica Neue"/>
               </a:rPr>
-              <a:t>Finding 1 — deep learning fails at this scale</a:t>
-            </a:r>
-          </a:p>
-        </p:txBody>
-      </p:sp>
-      <p:sp>
-        <p:nvSpPr>
-          <p:cNvPr id="5" name="TextBox 4"/>
+              <a:t>Every model loses to predicting the mean</a:t>
+            </a:r>
+          </a:p>
+        </p:txBody>
+      </p:sp>
+      <p:pic>
+        <p:nvPicPr>
+          <p:cNvPr id="5" name="Picture 4" descr="padr_scoreboard.png"/>
+          <p:cNvPicPr>
+            <a:picLocks noChangeAspect="1"/>
+          </p:cNvPicPr>
+          <p:nvPr/>
+        </p:nvPicPr>
+        <p:blipFill>
+          <a:blip r:embed="rId2"/>
+          <a:stretch>
+            <a:fillRect/>
+          </a:stretch>
+        </p:blipFill>
+        <p:spPr>
+          <a:xfrm>
+            <a:off x="2028075" y="1783080"/>
+            <a:ext cx="8135545" cy="4343400"/>
+          </a:xfrm>
+          <a:prstGeom prst="rect">
+            <a:avLst/>
+          </a:prstGeom>
+        </p:spPr>
+      </p:pic>
+      <p:sp>
+        <p:nvSpPr>
+          <p:cNvPr id="6" name="TextBox 5"/>
           <p:cNvSpPr txBox="1"/>
           <p:nvPr/>
         </p:nvSpPr>
         <p:spPr>
           <a:xfrm>
-            <a:off x="777240" y="1691640"/>
-            <a:ext cx="10637215" cy="3749040"/>
+            <a:off x="777240" y="6272784"/>
+            <a:ext cx="10637215" cy="457200"/>
           </a:xfrm>
           <a:prstGeom prst="rect">
             <a:avLst/>
@@ -11842,317 +11616,6 @@
         </p:spPr>
         <p:txBody>
           <a:bodyPr wrap="square" anchor="t" lIns="0" rIns="0" tIns="0" bIns="0">
-            <a:spAutoFit/>
-          </a:bodyPr>
-          <a:lstStyle/>
-          <a:p>
-            <a:pPr algn="l">
-              <a:lnSpc>
-                <a:spcPct val="122000"/>
-              </a:lnSpc>
-              <a:spcBef>
-                <a:spcPts val="0"/>
-              </a:spcBef>
-              <a:spcAft>
-                <a:spcPts val="200"/>
-              </a:spcAft>
-            </a:pPr>
-            <a:r>
-              <a:rPr sz="1700" b="1" i="0">
-                <a:solidFill>
-                  <a:srgbClr val="EB6834"/>
-                </a:solidFill>
-                <a:latin typeface="Helvetica Neue"/>
-              </a:rPr>
-              <a:t>▸  </a:t>
-            </a:r>
-            <a:r>
-              <a:rPr sz="1700" b="1" i="0">
-                <a:solidFill>
-                  <a:srgbClr val="0B0B0B"/>
-                </a:solidFill>
-                <a:latin typeface="Helvetica Neue"/>
-              </a:rPr>
-              <a:t>The outcome  </a:t>
-            </a:r>
-            <a:r>
-              <a:rPr sz="1700" b="0" i="0">
-                <a:solidFill>
-                  <a:srgbClr val="52514E"/>
-                </a:solidFill>
-                <a:latin typeface="Helvetica Neue"/>
-              </a:rPr>
-              <a:t>all four deep architectures score below a constant-mean predictor; the paired Wilcoxon test rejects parity with the classical family at p &lt; 0.0001</a:t>
-            </a:r>
-          </a:p>
-          <a:p>
-            <a:pPr algn="l">
-              <a:lnSpc>
-                <a:spcPct val="122000"/>
-              </a:lnSpc>
-              <a:spcBef>
-                <a:spcPts val="1100"/>
-              </a:spcBef>
-              <a:spcAft>
-                <a:spcPts val="200"/>
-              </a:spcAft>
-            </a:pPr>
-            <a:r>
-              <a:rPr sz="1700" b="1" i="0">
-                <a:solidFill>
-                  <a:srgbClr val="EB6834"/>
-                </a:solidFill>
-                <a:latin typeface="Helvetica Neue"/>
-              </a:rPr>
-              <a:t>▸  </a:t>
-            </a:r>
-            <a:r>
-              <a:rPr sz="1700" b="1" i="0">
-                <a:solidFill>
-                  <a:srgbClr val="0B0B0B"/>
-                </a:solidFill>
-                <a:latin typeface="Helvetica Neue"/>
-              </a:rPr>
-              <a:t>The hybrid CNN-LSTM does not beat its own components  </a:t>
-            </a:r>
-            <a:r>
-              <a:rPr sz="1700" b="0" i="0">
-                <a:solidFill>
-                  <a:srgbClr val="52514E"/>
-                </a:solidFill>
-                <a:latin typeface="Helvetica Neue"/>
-              </a:rPr>
-              <a:t>it sits between the CNN and the LSTM</a:t>
-            </a:r>
-          </a:p>
-          <a:p>
-            <a:pPr algn="l">
-              <a:lnSpc>
-                <a:spcPct val="122000"/>
-              </a:lnSpc>
-              <a:spcBef>
-                <a:spcPts val="1100"/>
-              </a:spcBef>
-              <a:spcAft>
-                <a:spcPts val="200"/>
-              </a:spcAft>
-            </a:pPr>
-            <a:r>
-              <a:rPr sz="1700" b="1" i="0">
-                <a:solidFill>
-                  <a:srgbClr val="EB6834"/>
-                </a:solidFill>
-                <a:latin typeface="Helvetica Neue"/>
-              </a:rPr>
-              <a:t>▸  </a:t>
-            </a:r>
-            <a:r>
-              <a:rPr sz="1700" b="1" i="0">
-                <a:solidFill>
-                  <a:srgbClr val="0B0B0B"/>
-                </a:solidFill>
-                <a:latin typeface="Helvetica Neue"/>
-              </a:rPr>
-              <a:t>Why  </a:t>
-            </a:r>
-            <a:r>
-              <a:rPr sz="1700" b="0" i="0">
-                <a:solidFill>
-                  <a:srgbClr val="52514E"/>
-                </a:solidFill>
-                <a:latin typeface="Helvetica Neue"/>
-              </a:rPr>
-              <a:t>representation learning trades sample efficiency for expressive power — at 24 training records per fold there is nothing to trade with</a:t>
-            </a:r>
-          </a:p>
-          <a:p>
-            <a:pPr algn="l">
-              <a:lnSpc>
-                <a:spcPct val="122000"/>
-              </a:lnSpc>
-              <a:spcBef>
-                <a:spcPts val="1100"/>
-              </a:spcBef>
-              <a:spcAft>
-                <a:spcPts val="200"/>
-              </a:spcAft>
-            </a:pPr>
-            <a:r>
-              <a:rPr sz="1700" b="1" i="0">
-                <a:solidFill>
-                  <a:srgbClr val="EB6834"/>
-                </a:solidFill>
-                <a:latin typeface="Helvetica Neue"/>
-              </a:rPr>
-              <a:t>▸  </a:t>
-            </a:r>
-            <a:r>
-              <a:rPr sz="1700" b="1" i="0">
-                <a:solidFill>
-                  <a:srgbClr val="0B0B0B"/>
-                </a:solidFill>
-                <a:latin typeface="Helvetica Neue"/>
-              </a:rPr>
-              <a:t>It is not a bug  </a:t>
-            </a:r>
-            <a:r>
-              <a:rPr sz="1700" b="0" i="0">
-                <a:solidFill>
-                  <a:srgbClr val="52514E"/>
-                </a:solidFill>
-                <a:latin typeface="Helvetica Neue"/>
-              </a:rPr>
-              <a:t>the same code reaches R² 0.842 on a larger sample (slide 27)</a:t>
-            </a:r>
-          </a:p>
-          <a:p>
-            <a:pPr algn="l">
-              <a:lnSpc>
-                <a:spcPct val="122000"/>
-              </a:lnSpc>
-              <a:spcBef>
-                <a:spcPts val="1100"/>
-              </a:spcBef>
-              <a:spcAft>
-                <a:spcPts val="200"/>
-              </a:spcAft>
-            </a:pPr>
-            <a:r>
-              <a:rPr sz="1700" b="1" i="0">
-                <a:solidFill>
-                  <a:srgbClr val="EB6834"/>
-                </a:solidFill>
-                <a:latin typeface="Helvetica Neue"/>
-              </a:rPr>
-              <a:t>▸  </a:t>
-            </a:r>
-            <a:r>
-              <a:rPr sz="1700" b="1" i="0">
-                <a:solidFill>
-                  <a:srgbClr val="0B0B0B"/>
-                </a:solidFill>
-                <a:latin typeface="Helvetica Neue"/>
-              </a:rPr>
-              <a:t>It survives scale  </a:t>
-            </a:r>
-            <a:r>
-              <a:rPr sz="1700" b="0" i="0">
-                <a:solidFill>
-                  <a:srgbClr val="52514E"/>
-                </a:solidFill>
-                <a:latin typeface="Helvetica Neue"/>
-              </a:rPr>
-              <a:t>even at ~160 records the classical models still lead 0.842 to 0.271</a:t>
-            </a:r>
-          </a:p>
-        </p:txBody>
-      </p:sp>
-      <p:sp>
-        <p:nvSpPr>
-          <p:cNvPr id="6" name="Rectangle 5"/>
-          <p:cNvSpPr/>
-          <p:nvPr/>
-        </p:nvSpPr>
-        <p:spPr>
-          <a:xfrm>
-            <a:off x="777240" y="5623560"/>
-            <a:ext cx="10637215" cy="731520"/>
-          </a:xfrm>
-          <a:prstGeom prst="rect">
-            <a:avLst/>
-          </a:prstGeom>
-          <a:solidFill>
-            <a:srgbClr val="F2F1EE"/>
-          </a:solidFill>
-          <a:ln>
-            <a:noFill/>
-          </a:ln>
-          <a:effectLst/>
-        </p:spPr>
-        <p:style>
-          <a:lnRef idx="1">
-            <a:schemeClr val="accent1"/>
-          </a:lnRef>
-          <a:fillRef idx="3">
-            <a:schemeClr val="accent1"/>
-          </a:fillRef>
-          <a:effectRef idx="2">
-            <a:schemeClr val="accent1"/>
-          </a:effectRef>
-          <a:fontRef idx="minor">
-            <a:schemeClr val="lt1"/>
-          </a:fontRef>
-        </p:style>
-        <p:txBody>
-          <a:bodyPr rtlCol="0" anchor="ctr"/>
-          <a:lstStyle/>
-          <a:p>
-            <a:pPr algn="ctr"/>
-          </a:p>
-        </p:txBody>
-      </p:sp>
-      <p:sp>
-        <p:nvSpPr>
-          <p:cNvPr id="7" name="Rectangle 6"/>
-          <p:cNvSpPr/>
-          <p:nvPr/>
-        </p:nvSpPr>
-        <p:spPr>
-          <a:xfrm>
-            <a:off x="777240" y="5623560"/>
-            <a:ext cx="54864" cy="731520"/>
-          </a:xfrm>
-          <a:prstGeom prst="rect">
-            <a:avLst/>
-          </a:prstGeom>
-          <a:solidFill>
-            <a:srgbClr val="EB6834"/>
-          </a:solidFill>
-          <a:ln>
-            <a:noFill/>
-          </a:ln>
-          <a:effectLst/>
-        </p:spPr>
-        <p:style>
-          <a:lnRef idx="1">
-            <a:schemeClr val="accent1"/>
-          </a:lnRef>
-          <a:fillRef idx="3">
-            <a:schemeClr val="accent1"/>
-          </a:fillRef>
-          <a:effectRef idx="2">
-            <a:schemeClr val="accent1"/>
-          </a:effectRef>
-          <a:fontRef idx="minor">
-            <a:schemeClr val="lt1"/>
-          </a:fontRef>
-        </p:style>
-        <p:txBody>
-          <a:bodyPr rtlCol="0" anchor="ctr"/>
-          <a:lstStyle/>
-          <a:p>
-            <a:pPr algn="ctr"/>
-          </a:p>
-        </p:txBody>
-      </p:sp>
-      <p:sp>
-        <p:nvSpPr>
-          <p:cNvPr id="8" name="TextBox 7"/>
-          <p:cNvSpPr txBox="1"/>
-          <p:nvPr/>
-        </p:nvSpPr>
-        <p:spPr>
-          <a:xfrm>
-            <a:off x="1051560" y="5623560"/>
-            <a:ext cx="10088575" cy="731520"/>
-          </a:xfrm>
-          <a:prstGeom prst="rect">
-            <a:avLst/>
-          </a:prstGeom>
-          <a:noFill/>
-        </p:spPr>
-        <p:txBody>
-          <a:bodyPr wrap="square" anchor="ctr" lIns="0" rIns="0" tIns="0" bIns="0">
             <a:spAutoFit/>
           </a:bodyPr>
           <a:lstStyle/>
@@ -12166,13 +11629,13 @@
               </a:spcAft>
             </a:pPr>
             <a:r>
-              <a:rPr sz="1500" b="1" i="0">
-                <a:solidFill>
-                  <a:srgbClr val="0D366B"/>
-                </a:solidFill>
-                <a:latin typeface="Helvetica Neue"/>
-              </a:rPr>
-              <a:t>Actionable guidance the literature does not give: at this sample size, do not start with deep learning.</a:t>
+              <a:rPr sz="1300" b="0" i="0">
+                <a:solidFill>
+                  <a:srgbClr val="8A8983"/>
+                </a:solidFill>
+                <a:latin typeface="Helvetica Neue"/>
+              </a:rPr>
+              <a:t>Leave-one-year-out R² on the corrected target. The oracle row uses the held-out year's own mean and is not achievable — it bounds what perfect knowledge of the year effect would buy.</a:t>
             </a:r>
           </a:p>
         </p:txBody>
@@ -12326,14 +11789,14 @@
                 </a:solidFill>
                 <a:latin typeface="Helvetica Neue"/>
               </a:rPr>
-              <a:t>Finding 2 — the agronomic prior earns its place</a:t>
+              <a:t>Why: the stress index cannot move far enough</a:t>
             </a:r>
           </a:p>
         </p:txBody>
       </p:sp>
       <p:pic>
         <p:nvPicPr>
-          <p:cNvPr id="5" name="Picture 4" descr="physics_ablation.png"/>
+          <p:cNvPr id="5" name="Picture 4" descr="stress_vs_yield.png"/>
           <p:cNvPicPr>
             <a:picLocks noChangeAspect="1"/>
           </p:cNvPicPr>
@@ -12347,8 +11810,8 @@
         </p:blipFill>
         <p:spPr>
           <a:xfrm>
-            <a:off x="2648824" y="1783080"/>
-            <a:ext cx="6894047" cy="3931920"/>
+            <a:off x="777240" y="1783080"/>
+            <a:ext cx="10637215" cy="4058695"/>
           </a:xfrm>
           <a:prstGeom prst="rect">
             <a:avLst/>
@@ -12363,7 +11826,7 @@
         </p:nvSpPr>
         <p:spPr>
           <a:xfrm>
-            <a:off x="777240" y="5861304"/>
+            <a:off x="777240" y="5988079"/>
             <a:ext cx="10637215" cy="457200"/>
           </a:xfrm>
           <a:prstGeom prst="rect">
@@ -12392,7 +11855,7 @@
                 </a:solidFill>
                 <a:latin typeface="Helvetica Neue"/>
               </a:rPr>
-              <a:t>Backbone alone is worse than the mean. Learner alone reaches 0.020. Together they reach 0.091 — a +0.070 lift over the same learner.</a:t>
+              <a:t>Stress index varies 8%. Observed yield varies 35%. Thermal stress is near-constant in the tropics, and water deficit almost never binds under tank irrigation.</a:t>
             </a:r>
           </a:p>
         </p:txBody>
@@ -12504,7 +11967,7 @@
                 </a:solidFill>
                 <a:latin typeface="Helvetica Neue"/>
               </a:rPr>
-              <a:t>RESULTS</a:t>
+              <a:t>RESULTS — THE LINCHPIN</a:t>
             </a:r>
           </a:p>
         </p:txBody>
@@ -12546,14 +12009,14 @@
                 </a:solidFill>
                 <a:latin typeface="Helvetica Neue"/>
               </a:rPr>
-              <a:t>Finding 3 — stacking beats the mean, not the best model</a:t>
+              <a:t>Would we have found a signal if one were there?</a:t>
             </a:r>
           </a:p>
         </p:txBody>
       </p:sp>
       <p:pic>
         <p:nvPicPr>
-          <p:cNvPr id="5" name="Picture 4" descr="stacking.png"/>
+          <p:cNvPr id="5" name="Picture 4" descr="power_curve.png"/>
           <p:cNvPicPr>
             <a:picLocks noChangeAspect="1"/>
           </p:cNvPicPr>
@@ -12567,8 +12030,8 @@
         </p:blipFill>
         <p:spPr>
           <a:xfrm>
-            <a:off x="2241024" y="1783080"/>
-            <a:ext cx="7709647" cy="3931920"/>
+            <a:off x="1892342" y="1783080"/>
+            <a:ext cx="8407010" cy="4343400"/>
           </a:xfrm>
           <a:prstGeom prst="rect">
             <a:avLst/>
@@ -12583,7 +12046,7 @@
         </p:nvSpPr>
         <p:spPr>
           <a:xfrm>
-            <a:off x="777240" y="5861304"/>
+            <a:off x="777240" y="6272784"/>
             <a:ext cx="10637215" cy="457200"/>
           </a:xfrm>
           <a:prstGeom prst="rect">
@@ -12612,7 +12075,7 @@
                 </a:solidFill>
                 <a:latin typeface="Helvetica Neue"/>
               </a:rPr>
-              <a:t>The learned convex blend clearly beats the equal-weight mean — the forecast-combination puzzle does not hold here — but no blend beats the single physics-residual hybrid.</a:t>
+              <a:t>On simulated panels PADR recovers a weather signal driving as little as 6% of yield variance at n=28. It recovered none from the real data — so the true signal is below 6%.</a:t>
             </a:r>
           </a:p>
         </p:txBody>
@@ -12724,7 +12187,7 @@
                 </a:solidFill>
                 <a:latin typeface="Helvetica Neue"/>
               </a:rPr>
-              <a:t>RESULTS</a:t>
+              <a:t>RESULTS — THE POSITIVE FINDING</a:t>
             </a:r>
           </a:p>
         </p:txBody>
@@ -12766,14 +12229,14 @@
                 </a:solidFill>
                 <a:latin typeface="Helvetica Neue"/>
               </a:rPr>
-              <a:t>Which data source is worth paying for?</a:t>
+              <a:t>FAO-33 overstates weather sensitivity for this crop</a:t>
             </a:r>
           </a:p>
         </p:txBody>
       </p:sp>
       <p:pic>
         <p:nvPicPr>
-          <p:cNvPr id="5" name="Picture 4" descr="ablation_sources.png"/>
+          <p:cNvPr id="5" name="Picture 4" descr="learned_constants.png"/>
           <p:cNvPicPr>
             <a:picLocks noChangeAspect="1"/>
           </p:cNvPicPr>
@@ -12787,8 +12250,8 @@
         </p:blipFill>
         <p:spPr>
           <a:xfrm>
-            <a:off x="1999590" y="1783080"/>
-            <a:ext cx="8192514" cy="3931920"/>
+            <a:off x="777240" y="1783080"/>
+            <a:ext cx="10637215" cy="4172355"/>
           </a:xfrm>
           <a:prstGeom prst="rect">
             <a:avLst/>
@@ -12803,7 +12266,7 @@
         </p:nvSpPr>
         <p:spPr>
           <a:xfrm>
-            <a:off x="777240" y="5861304"/>
+            <a:off x="777240" y="6101739"/>
             <a:ext cx="10637215" cy="457200"/>
           </a:xfrm>
           <a:prstGeom prst="rect">
@@ -12832,7 +12295,7 @@
                 </a:solidFill>
                 <a:latin typeface="Helvetica Neue"/>
               </a:rPr>
-              <a:t>Six configurations, identical model, protocol and seed. Only the full set approaches the baseline.</a:t>
+              <a:t>Pinning the coefficients to published values produces the right amount of variation (35%) but the worst score of any configuration (R² −1.54). T_opt and W_max are recovered to within 3%; Ky and T_crit are NOT identifiable at n=28 and are not claimed.</a:t>
             </a:r>
           </a:p>
         </p:txBody>
@@ -12986,14 +12449,14 @@
                 </a:solidFill>
                 <a:latin typeface="Helvetica Neue"/>
               </a:rPr>
-              <a:t>Predictability varies sharply by district</a:t>
+              <a:t>Two claims survived. Two did not.</a:t>
             </a:r>
           </a:p>
         </p:txBody>
       </p:sp>
       <p:pic>
         <p:nvPicPr>
-          <p:cNvPr id="5" name="Picture 4" descr="per_district.png"/>
+          <p:cNvPr id="5" name="Picture 4" descr="ablation_claims.png"/>
           <p:cNvPicPr>
             <a:picLocks noChangeAspect="1"/>
           </p:cNvPicPr>
@@ -13007,8 +12470,8 @@
         </p:blipFill>
         <p:spPr>
           <a:xfrm>
-            <a:off x="1923775" y="1783080"/>
-            <a:ext cx="8344145" cy="3840480"/>
+            <a:off x="1548642" y="1783080"/>
+            <a:ext cx="9094411" cy="4343400"/>
           </a:xfrm>
           <a:prstGeom prst="rect">
             <a:avLst/>
@@ -13023,7 +12486,7 @@
         </p:nvSpPr>
         <p:spPr>
           <a:xfrm>
-            <a:off x="777240" y="5769864"/>
+            <a:off x="777240" y="6272784"/>
             <a:ext cx="10637215" cy="457200"/>
           </a:xfrm>
           <a:prstGeom prst="rect">
@@ -13052,7 +12515,7 @@
                 </a:solidFill>
                 <a:latin typeface="Helvetica Neue"/>
               </a:rPr>
-              <a:t>Anuradhapura is most predictable; Kurunegala is worst by R² but better than Matale by absolute error.</a:t>
+              <a:t>Each design claim tested against its own control. Learning the physics and moderate shrinkage are supported; thermal-time indexing and the waterlogging term are not.</a:t>
             </a:r>
           </a:p>
         </p:txBody>
@@ -13206,14 +12669,14 @@
                 </a:solidFill>
                 <a:latin typeface="Helvetica Neue"/>
               </a:rPr>
-              <a:t>What drives the forecast</a:t>
+              <a:t>When does weather matter for onion?</a:t>
             </a:r>
           </a:p>
         </p:txBody>
       </p:sp>
       <p:pic>
         <p:nvPicPr>
-          <p:cNvPr id="5" name="Picture 4" descr="shap_top.png"/>
+          <p:cNvPr id="5" name="Picture 4" descr="beta_curve.png"/>
           <p:cNvPicPr>
             <a:picLocks noChangeAspect="1"/>
           </p:cNvPicPr>
@@ -13227,8 +12690,8 @@
         </p:blipFill>
         <p:spPr>
           <a:xfrm>
-            <a:off x="2123806" y="1783080"/>
-            <a:ext cx="7944083" cy="3931920"/>
+            <a:off x="1885681" y="1783080"/>
+            <a:ext cx="8420333" cy="4343400"/>
           </a:xfrm>
           <a:prstGeom prst="rect">
             <a:avLst/>
@@ -13243,7 +12706,7 @@
         </p:nvSpPr>
         <p:spPr>
           <a:xfrm>
-            <a:off x="777240" y="5861304"/>
+            <a:off x="777240" y="6272784"/>
             <a:ext cx="10637215" cy="457200"/>
           </a:xfrm>
           <a:prstGeom prst="rect">
@@ -13272,7 +12735,7 @@
                 </a:solidFill>
                 <a:latin typeface="Helvetica Neue"/>
               </a:rPr>
-              <a:t>Two of the three engineered interaction terms outrank every raw measurement they were built from.</a:t>
+              <a:t>Estimated sensitivity declines monotonically — roughly seven times more weight on establishment than on harvest. Band shows the range across folds.</a:t>
             </a:r>
           </a:p>
         </p:txBody>
@@ -13426,77 +12889,464 @@
                 </a:solidFill>
                 <a:latin typeface="Helvetica Neue"/>
               </a:rPr>
-              <a:t>Every forecast ships with a calibrated interval</a:t>
-            </a:r>
-          </a:p>
-        </p:txBody>
-      </p:sp>
-      <p:pic>
-        <p:nvPicPr>
-          <p:cNvPr id="5" name="Picture 4" descr="conformal.png"/>
-          <p:cNvPicPr>
-            <a:picLocks noChangeAspect="1"/>
-          </p:cNvPicPr>
-          <p:nvPr/>
-        </p:nvPicPr>
-        <p:blipFill>
-          <a:blip r:embed="rId2"/>
-          <a:stretch>
-            <a:fillRect/>
-          </a:stretch>
-        </p:blipFill>
-        <p:spPr>
-          <a:xfrm>
-            <a:off x="2420822" y="1783080"/>
-            <a:ext cx="7350050" cy="3931920"/>
-          </a:xfrm>
-          <a:prstGeom prst="rect">
-            <a:avLst/>
-          </a:prstGeom>
-        </p:spPr>
-      </p:pic>
-      <p:sp>
-        <p:nvSpPr>
-          <p:cNvPr id="6" name="TextBox 5"/>
-          <p:cNvSpPr txBox="1"/>
-          <p:nvPr/>
-        </p:nvSpPr>
-        <p:spPr>
-          <a:xfrm>
-            <a:off x="777240" y="5861304"/>
-            <a:ext cx="10637215" cy="457200"/>
-          </a:xfrm>
-          <a:prstGeom prst="rect">
-            <a:avLst/>
-          </a:prstGeom>
-          <a:noFill/>
-        </p:spPr>
-        <p:txBody>
-          <a:bodyPr wrap="square" anchor="t" lIns="0" rIns="0" tIns="0" bIns="0">
-            <a:spAutoFit/>
-          </a:bodyPr>
-          <a:lstStyle/>
-          <a:p>
-            <a:pPr algn="l">
-              <a:spcBef>
-                <a:spcPts val="0"/>
-              </a:spcBef>
-              <a:spcAft>
-                <a:spcPts val="600"/>
-              </a:spcAft>
-            </a:pPr>
-            <a:r>
-              <a:rPr sz="1300" b="0" i="0">
-                <a:solidFill>
-                  <a:srgbClr val="8A8983"/>
-                </a:solidFill>
-                <a:latin typeface="Helvetica Neue"/>
-              </a:rPr>
-              <a:t>Split-conformal, distribution-free, at 90% nominal coverage. Interval width ranks the models the same way point error does.</a:t>
-            </a:r>
-          </a:p>
-        </p:txBody>
-      </p:sp>
+              <a:t>Honest intervals — and what they reveal</a:t>
+            </a:r>
+          </a:p>
+        </p:txBody>
+      </p:sp>
+      <p:graphicFrame>
+        <p:nvGraphicFramePr>
+          <p:cNvPr id="5" name="Table 4"/>
+          <p:cNvGraphicFramePr>
+            <a:graphicFrameLocks noGrp="1"/>
+          </p:cNvGraphicFramePr>
+          <p:nvPr/>
+        </p:nvGraphicFramePr>
+        <p:xfrm>
+          <a:off x="777240" y="1920240"/>
+          <a:ext cx="10637213" cy="2304288"/>
+        </p:xfrm>
+        <a:graphic>
+          <a:graphicData uri="http://schemas.openxmlformats.org/drawingml/2006/table">
+            <a:tbl>
+              <a:tblPr firstRow="1" bandRow="1">
+                <a:tableStyleId>{5C22544A-7EE6-4342-B048-85BDC9FD1C3A}</a:tableStyleId>
+              </a:tblPr>
+              <a:tblGrid>
+                <a:gridCol w="4702768"/>
+                <a:gridCol w="2687296"/>
+                <a:gridCol w="3247149"/>
+              </a:tblGrid>
+              <a:tr h="384048">
+                <a:tc>
+                  <a:txBody>
+                    <a:bodyPr wrap="square"/>
+                    <a:lstStyle/>
+                    <a:p>
+                      <a:pPr algn="l"/>
+                      <a:r>
+                        <a:rPr sz="1200" b="1" i="0">
+                          <a:solidFill>
+                            <a:srgbClr val="FFFFFF"/>
+                          </a:solidFill>
+                          <a:latin typeface="Helvetica Neue"/>
+                        </a:rPr>
+                        <a:t>Model</a:t>
+                      </a:r>
+                    </a:p>
+                  </a:txBody>
+                  <a:tcPr marL="91440" marR="91440">
+                    <a:solidFill>
+                      <a:srgbClr val="0D366B"/>
+                    </a:solidFill>
+                  </a:tcPr>
+                </a:tc>
+                <a:tc>
+                  <a:txBody>
+                    <a:bodyPr wrap="square"/>
+                    <a:lstStyle/>
+                    <a:p>
+                      <a:pPr algn="l"/>
+                      <a:r>
+                        <a:rPr sz="1200" b="1" i="0">
+                          <a:solidFill>
+                            <a:srgbClr val="FFFFFF"/>
+                          </a:solidFill>
+                          <a:latin typeface="Helvetica Neue"/>
+                        </a:rPr>
+                        <a:t>Coverage</a:t>
+                      </a:r>
+                    </a:p>
+                  </a:txBody>
+                  <a:tcPr marL="91440" marR="91440">
+                    <a:solidFill>
+                      <a:srgbClr val="0D366B"/>
+                    </a:solidFill>
+                  </a:tcPr>
+                </a:tc>
+                <a:tc>
+                  <a:txBody>
+                    <a:bodyPr wrap="square"/>
+                    <a:lstStyle/>
+                    <a:p>
+                      <a:pPr algn="l"/>
+                      <a:r>
+                        <a:rPr sz="1200" b="1" i="0">
+                          <a:solidFill>
+                            <a:srgbClr val="FFFFFF"/>
+                          </a:solidFill>
+                          <a:latin typeface="Helvetica Neue"/>
+                        </a:rPr>
+                        <a:t>Half-width (MT/ha)</a:t>
+                      </a:r>
+                    </a:p>
+                  </a:txBody>
+                  <a:tcPr marL="91440" marR="91440">
+                    <a:solidFill>
+                      <a:srgbClr val="0D366B"/>
+                    </a:solidFill>
+                  </a:tcPr>
+                </a:tc>
+              </a:tr>
+              <a:tr h="384048">
+                <a:tc>
+                  <a:txBody>
+                    <a:bodyPr wrap="square"/>
+                    <a:lstStyle/>
+                    <a:p>
+                      <a:pPr algn="l"/>
+                      <a:r>
+                        <a:rPr sz="1150" b="0" i="0">
+                          <a:solidFill>
+                            <a:srgbClr val="52514E"/>
+                          </a:solidFill>
+                          <a:latin typeface="Helvetica Neue"/>
+                        </a:rPr>
+                        <a:t>Oracle year-mean (not achievable)</a:t>
+                      </a:r>
+                    </a:p>
+                  </a:txBody>
+                  <a:tcPr marL="91440" marR="91440">
+                    <a:solidFill>
+                      <a:srgbClr val="F7F6F4"/>
+                    </a:solidFill>
+                  </a:tcPr>
+                </a:tc>
+                <a:tc>
+                  <a:txBody>
+                    <a:bodyPr wrap="square"/>
+                    <a:lstStyle/>
+                    <a:p>
+                      <a:pPr algn="l"/>
+                      <a:r>
+                        <a:rPr sz="1150" b="0" i="0">
+                          <a:solidFill>
+                            <a:srgbClr val="52514E"/>
+                          </a:solidFill>
+                          <a:latin typeface="Helvetica Neue"/>
+                        </a:rPr>
+                        <a:t>0.929</a:t>
+                      </a:r>
+                    </a:p>
+                  </a:txBody>
+                  <a:tcPr marL="91440" marR="91440">
+                    <a:solidFill>
+                      <a:srgbClr val="F7F6F4"/>
+                    </a:solidFill>
+                  </a:tcPr>
+                </a:tc>
+                <a:tc>
+                  <a:txBody>
+                    <a:bodyPr wrap="square"/>
+                    <a:lstStyle/>
+                    <a:p>
+                      <a:pPr algn="l"/>
+                      <a:r>
+                        <a:rPr sz="1150" b="0" i="0">
+                          <a:solidFill>
+                            <a:srgbClr val="52514E"/>
+                          </a:solidFill>
+                          <a:latin typeface="Helvetica Neue"/>
+                        </a:rPr>
+                        <a:t>6.70</a:t>
+                      </a:r>
+                    </a:p>
+                  </a:txBody>
+                  <a:tcPr marL="91440" marR="91440">
+                    <a:solidFill>
+                      <a:srgbClr val="F7F6F4"/>
+                    </a:solidFill>
+                  </a:tcPr>
+                </a:tc>
+              </a:tr>
+              <a:tr h="384048">
+                <a:tc>
+                  <a:txBody>
+                    <a:bodyPr wrap="square"/>
+                    <a:lstStyle/>
+                    <a:p>
+                      <a:pPr algn="l"/>
+                      <a:r>
+                        <a:rPr sz="1150" b="0" i="0">
+                          <a:solidFill>
+                            <a:srgbClr val="52514E"/>
+                          </a:solidFill>
+                          <a:latin typeface="Helvetica Neue"/>
+                        </a:rPr>
+                        <a:t>Train mean</a:t>
+                      </a:r>
+                    </a:p>
+                  </a:txBody>
+                  <a:tcPr marL="91440" marR="91440">
+                    <a:solidFill>
+                      <a:srgbClr val="FCFCFB"/>
+                    </a:solidFill>
+                  </a:tcPr>
+                </a:tc>
+                <a:tc>
+                  <a:txBody>
+                    <a:bodyPr wrap="square"/>
+                    <a:lstStyle/>
+                    <a:p>
+                      <a:pPr algn="l"/>
+                      <a:r>
+                        <a:rPr sz="1150" b="0" i="0">
+                          <a:solidFill>
+                            <a:srgbClr val="52514E"/>
+                          </a:solidFill>
+                          <a:latin typeface="Helvetica Neue"/>
+                        </a:rPr>
+                        <a:t>0.893</a:t>
+                      </a:r>
+                    </a:p>
+                  </a:txBody>
+                  <a:tcPr marL="91440" marR="91440">
+                    <a:solidFill>
+                      <a:srgbClr val="FCFCFB"/>
+                    </a:solidFill>
+                  </a:tcPr>
+                </a:tc>
+                <a:tc>
+                  <a:txBody>
+                    <a:bodyPr wrap="square"/>
+                    <a:lstStyle/>
+                    <a:p>
+                      <a:pPr algn="l"/>
+                      <a:r>
+                        <a:rPr sz="1150" b="0" i="0">
+                          <a:solidFill>
+                            <a:srgbClr val="52514E"/>
+                          </a:solidFill>
+                          <a:latin typeface="Helvetica Neue"/>
+                        </a:rPr>
+                        <a:t>14.90</a:t>
+                      </a:r>
+                    </a:p>
+                  </a:txBody>
+                  <a:tcPr marL="91440" marR="91440">
+                    <a:solidFill>
+                      <a:srgbClr val="FCFCFB"/>
+                    </a:solidFill>
+                  </a:tcPr>
+                </a:tc>
+              </a:tr>
+              <a:tr h="384048">
+                <a:tc>
+                  <a:txBody>
+                    <a:bodyPr wrap="square"/>
+                    <a:lstStyle/>
+                    <a:p>
+                      <a:pPr algn="l"/>
+                      <a:r>
+                        <a:rPr sz="1150" b="0" i="0">
+                          <a:solidFill>
+                            <a:srgbClr val="52514E"/>
+                          </a:solidFill>
+                          <a:latin typeface="Helvetica Neue"/>
+                        </a:rPr>
+                        <a:t>PADR</a:t>
+                      </a:r>
+                    </a:p>
+                  </a:txBody>
+                  <a:tcPr marL="91440" marR="91440">
+                    <a:solidFill>
+                      <a:srgbClr val="F7F6F4"/>
+                    </a:solidFill>
+                  </a:tcPr>
+                </a:tc>
+                <a:tc>
+                  <a:txBody>
+                    <a:bodyPr wrap="square"/>
+                    <a:lstStyle/>
+                    <a:p>
+                      <a:pPr algn="l"/>
+                      <a:r>
+                        <a:rPr sz="1150" b="0" i="0">
+                          <a:solidFill>
+                            <a:srgbClr val="52514E"/>
+                          </a:solidFill>
+                          <a:latin typeface="Helvetica Neue"/>
+                        </a:rPr>
+                        <a:t>0.893</a:t>
+                      </a:r>
+                    </a:p>
+                  </a:txBody>
+                  <a:tcPr marL="91440" marR="91440">
+                    <a:solidFill>
+                      <a:srgbClr val="F7F6F4"/>
+                    </a:solidFill>
+                  </a:tcPr>
+                </a:tc>
+                <a:tc>
+                  <a:txBody>
+                    <a:bodyPr wrap="square"/>
+                    <a:lstStyle/>
+                    <a:p>
+                      <a:pPr algn="l"/>
+                      <a:r>
+                        <a:rPr sz="1150" b="0" i="0">
+                          <a:solidFill>
+                            <a:srgbClr val="52514E"/>
+                          </a:solidFill>
+                          <a:latin typeface="Helvetica Neue"/>
+                        </a:rPr>
+                        <a:t>15.29</a:t>
+                      </a:r>
+                    </a:p>
+                  </a:txBody>
+                  <a:tcPr marL="91440" marR="91440">
+                    <a:solidFill>
+                      <a:srgbClr val="F7F6F4"/>
+                    </a:solidFill>
+                  </a:tcPr>
+                </a:tc>
+              </a:tr>
+              <a:tr h="384048">
+                <a:tc>
+                  <a:txBody>
+                    <a:bodyPr wrap="square"/>
+                    <a:lstStyle/>
+                    <a:p>
+                      <a:pPr algn="l"/>
+                      <a:r>
+                        <a:rPr sz="1150" b="0" i="0">
+                          <a:solidFill>
+                            <a:srgbClr val="52514E"/>
+                          </a:solidFill>
+                          <a:latin typeface="Helvetica Neue"/>
+                        </a:rPr>
+                        <a:t>XGBoost</a:t>
+                      </a:r>
+                    </a:p>
+                  </a:txBody>
+                  <a:tcPr marL="91440" marR="91440">
+                    <a:solidFill>
+                      <a:srgbClr val="FCFCFB"/>
+                    </a:solidFill>
+                  </a:tcPr>
+                </a:tc>
+                <a:tc>
+                  <a:txBody>
+                    <a:bodyPr wrap="square"/>
+                    <a:lstStyle/>
+                    <a:p>
+                      <a:pPr algn="l"/>
+                      <a:r>
+                        <a:rPr sz="1150" b="0" i="0">
+                          <a:solidFill>
+                            <a:srgbClr val="52514E"/>
+                          </a:solidFill>
+                          <a:latin typeface="Helvetica Neue"/>
+                        </a:rPr>
+                        <a:t>0.929</a:t>
+                      </a:r>
+                    </a:p>
+                  </a:txBody>
+                  <a:tcPr marL="91440" marR="91440">
+                    <a:solidFill>
+                      <a:srgbClr val="FCFCFB"/>
+                    </a:solidFill>
+                  </a:tcPr>
+                </a:tc>
+                <a:tc>
+                  <a:txBody>
+                    <a:bodyPr wrap="square"/>
+                    <a:lstStyle/>
+                    <a:p>
+                      <a:pPr algn="l"/>
+                      <a:r>
+                        <a:rPr sz="1150" b="0" i="0">
+                          <a:solidFill>
+                            <a:srgbClr val="52514E"/>
+                          </a:solidFill>
+                          <a:latin typeface="Helvetica Neue"/>
+                        </a:rPr>
+                        <a:t>16.42</a:t>
+                      </a:r>
+                    </a:p>
+                  </a:txBody>
+                  <a:tcPr marL="91440" marR="91440">
+                    <a:solidFill>
+                      <a:srgbClr val="FCFCFB"/>
+                    </a:solidFill>
+                  </a:tcPr>
+                </a:tc>
+              </a:tr>
+              <a:tr h="384048">
+                <a:tc>
+                  <a:txBody>
+                    <a:bodyPr wrap="square"/>
+                    <a:lstStyle/>
+                    <a:p>
+                      <a:pPr algn="l"/>
+                      <a:r>
+                        <a:rPr sz="1150" b="0" i="0">
+                          <a:solidFill>
+                            <a:srgbClr val="52514E"/>
+                          </a:solidFill>
+                          <a:latin typeface="Helvetica Neue"/>
+                        </a:rPr>
+                        <a:t>Random Forest</a:t>
+                      </a:r>
+                    </a:p>
+                  </a:txBody>
+                  <a:tcPr marL="91440" marR="91440">
+                    <a:solidFill>
+                      <a:srgbClr val="F7F6F4"/>
+                    </a:solidFill>
+                  </a:tcPr>
+                </a:tc>
+                <a:tc>
+                  <a:txBody>
+                    <a:bodyPr wrap="square"/>
+                    <a:lstStyle/>
+                    <a:p>
+                      <a:pPr algn="l"/>
+                      <a:r>
+                        <a:rPr sz="1150" b="0" i="0">
+                          <a:solidFill>
+                            <a:srgbClr val="52514E"/>
+                          </a:solidFill>
+                          <a:latin typeface="Helvetica Neue"/>
+                        </a:rPr>
+                        <a:t>0.929</a:t>
+                      </a:r>
+                    </a:p>
+                  </a:txBody>
+                  <a:tcPr marL="91440" marR="91440">
+                    <a:solidFill>
+                      <a:srgbClr val="F7F6F4"/>
+                    </a:solidFill>
+                  </a:tcPr>
+                </a:tc>
+                <a:tc>
+                  <a:txBody>
+                    <a:bodyPr wrap="square"/>
+                    <a:lstStyle/>
+                    <a:p>
+                      <a:pPr algn="l"/>
+                      <a:r>
+                        <a:rPr sz="1150" b="0" i="0">
+                          <a:solidFill>
+                            <a:srgbClr val="52514E"/>
+                          </a:solidFill>
+                          <a:latin typeface="Helvetica Neue"/>
+                        </a:rPr>
+                        <a:t>17.63</a:t>
+                      </a:r>
+                    </a:p>
+                  </a:txBody>
+                  <a:tcPr marL="91440" marR="91440">
+                    <a:solidFill>
+                      <a:srgbClr val="F7F6F4"/>
+                    </a:solidFill>
+                  </a:tcPr>
+                </a:tc>
+              </a:tr>
+            </a:tbl>
+          </a:graphicData>
+        </a:graphic>
+      </p:graphicFrame>
     </p:spTree>
   </p:cSld>
   <p:clrMapOvr>
@@ -13604,7 +13454,7 @@
                 </a:solidFill>
                 <a:latin typeface="Helvetica Neue"/>
               </a:rPr>
-              <a:t>ARCHITECTURE VALIDATION</a:t>
+              <a:t>CORRECTIONS</a:t>
             </a:r>
           </a:p>
         </p:txBody>
@@ -13646,45 +13496,21 @@
                 </a:solidFill>
                 <a:latin typeface="Helvetica Neue"/>
               </a:rPr>
-              <a:t>Is the pipeline correct? Yes — and here is the proof</a:t>
-            </a:r>
-          </a:p>
-        </p:txBody>
-      </p:sp>
-      <p:pic>
-        <p:nvPicPr>
-          <p:cNvPr id="5" name="Picture 4" descr="sample_size.png"/>
-          <p:cNvPicPr>
-            <a:picLocks noChangeAspect="1"/>
-          </p:cNvPicPr>
-          <p:nvPr/>
-        </p:nvPicPr>
-        <p:blipFill>
-          <a:blip r:embed="rId2"/>
-          <a:stretch>
-            <a:fillRect/>
-          </a:stretch>
-        </p:blipFill>
-        <p:spPr>
-          <a:xfrm>
-            <a:off x="2848469" y="1783080"/>
-            <a:ext cx="6494756" cy="3840480"/>
-          </a:xfrm>
-          <a:prstGeom prst="rect">
-            <a:avLst/>
-          </a:prstGeom>
-        </p:spPr>
-      </p:pic>
-      <p:sp>
-        <p:nvSpPr>
-          <p:cNvPr id="6" name="TextBox 5"/>
+              <a:t>Two findings we are withdrawing</a:t>
+            </a:r>
+          </a:p>
+        </p:txBody>
+      </p:sp>
+      <p:sp>
+        <p:nvSpPr>
+          <p:cNvPr id="5" name="TextBox 4"/>
           <p:cNvSpPr txBox="1"/>
           <p:nvPr/>
         </p:nvSpPr>
         <p:spPr>
           <a:xfrm>
-            <a:off x="777240" y="5769864"/>
-            <a:ext cx="10637215" cy="457200"/>
+            <a:off x="777240" y="1691640"/>
+            <a:ext cx="10637215" cy="3749040"/>
           </a:xfrm>
           <a:prstGeom prst="rect">
             <a:avLst/>
@@ -13693,6 +13519,237 @@
         </p:spPr>
         <p:txBody>
           <a:bodyPr wrap="square" anchor="t" lIns="0" rIns="0" tIns="0" bIns="0">
+            <a:spAutoFit/>
+          </a:bodyPr>
+          <a:lstStyle/>
+          <a:p>
+            <a:pPr algn="l">
+              <a:lnSpc>
+                <a:spcPct val="122000"/>
+              </a:lnSpc>
+              <a:spcBef>
+                <a:spcPts val="0"/>
+              </a:spcBef>
+              <a:spcAft>
+                <a:spcPts val="200"/>
+              </a:spcAft>
+            </a:pPr>
+            <a:r>
+              <a:rPr sz="1550" b="1" i="0">
+                <a:solidFill>
+                  <a:srgbClr val="EB6834"/>
+                </a:solidFill>
+                <a:latin typeface="Helvetica Neue"/>
+              </a:rPr>
+              <a:t>▸  </a:t>
+            </a:r>
+            <a:r>
+              <a:rPr sz="1550" b="1" i="0">
+                <a:solidFill>
+                  <a:srgbClr val="0B0B0B"/>
+                </a:solidFill>
+                <a:latin typeface="Helvetica Neue"/>
+              </a:rPr>
+              <a:t>Withdrawn — 'deep learning fails at this scale'  </a:t>
+            </a:r>
+            <a:r>
+              <a:rPr sz="1550" b="0" i="0">
+                <a:solidFill>
+                  <a:srgbClr val="52514E"/>
+                </a:solidFill>
+                <a:latin typeface="Helvetica Neue"/>
+              </a:rPr>
+              <a:t>the sequence tensor fed to the LSTM and CNN models was manufactured from the seasonal aggregates through a fixed sine curve; it was a deterministic, invertible function of the tabular features the classical models already had, carrying zero extra information</a:t>
+            </a:r>
+          </a:p>
+          <a:p>
+            <a:pPr algn="l">
+              <a:lnSpc>
+                <a:spcPct val="122000"/>
+              </a:lnSpc>
+              <a:spcBef>
+                <a:spcPts val="800"/>
+              </a:spcBef>
+              <a:spcAft>
+                <a:spcPts val="200"/>
+              </a:spcAft>
+            </a:pPr>
+            <a:r>
+              <a:rPr sz="1550" b="1" i="0">
+                <a:solidFill>
+                  <a:srgbClr val="EB6834"/>
+                </a:solidFill>
+                <a:latin typeface="Helvetica Neue"/>
+              </a:rPr>
+              <a:t>▸  </a:t>
+            </a:r>
+            <a:r>
+              <a:rPr sz="1550" b="1" i="0">
+                <a:solidFill>
+                  <a:srgbClr val="0B0B0B"/>
+                </a:solidFill>
+                <a:latin typeface="Helvetica Neue"/>
+              </a:rPr>
+              <a:t>Withdrawn — 'synthetic R² 0.842 validates the architecture'  </a:t>
+            </a:r>
+            <a:r>
+              <a:rPr sz="1550" b="0" i="0">
+                <a:solidFill>
+                  <a:srgbClr val="52514E"/>
+                </a:solidFill>
+                <a:latin typeface="Helvetica Neue"/>
+              </a:rPr>
+              <a:t>that data was generated by a known functional form inside our own data loader, with the vegetation index built as a function of the yield it later predicted — recovering it proves only that an estimator can invert a function it was handed</a:t>
+            </a:r>
+          </a:p>
+          <a:p>
+            <a:pPr algn="l">
+              <a:lnSpc>
+                <a:spcPct val="122000"/>
+              </a:lnSpc>
+              <a:spcBef>
+                <a:spcPts val="800"/>
+              </a:spcBef>
+              <a:spcAft>
+                <a:spcPts val="200"/>
+              </a:spcAft>
+            </a:pPr>
+            <a:r>
+              <a:rPr sz="1550" b="1" i="0">
+                <a:solidFill>
+                  <a:srgbClr val="EB6834"/>
+                </a:solidFill>
+                <a:latin typeface="Helvetica Neue"/>
+              </a:rPr>
+              <a:t>▸  </a:t>
+            </a:r>
+            <a:r>
+              <a:rPr sz="1550" b="1" i="0">
+                <a:solidFill>
+                  <a:srgbClr val="0B0B0B"/>
+                </a:solidFill>
+                <a:latin typeface="Helvetica Neue"/>
+              </a:rPr>
+              <a:t>What replaced them  </a:t>
+            </a:r>
+            <a:r>
+              <a:rPr sz="1550" b="0" i="0">
+                <a:solidFill>
+                  <a:srgbClr val="52514E"/>
+                </a:solidFill>
+                <a:latin typeface="Helvetica Neue"/>
+              </a:rPr>
+              <a:t>37,988 genuine daily NASA POWER records now feed the sequence models; a proper comparison is stated as further work rather than claimed here</a:t>
+            </a:r>
+          </a:p>
+        </p:txBody>
+      </p:sp>
+      <p:sp>
+        <p:nvSpPr>
+          <p:cNvPr id="6" name="Rectangle 5"/>
+          <p:cNvSpPr/>
+          <p:nvPr/>
+        </p:nvSpPr>
+        <p:spPr>
+          <a:xfrm>
+            <a:off x="777240" y="5623560"/>
+            <a:ext cx="10637215" cy="731520"/>
+          </a:xfrm>
+          <a:prstGeom prst="rect">
+            <a:avLst/>
+          </a:prstGeom>
+          <a:solidFill>
+            <a:srgbClr val="F2F1EE"/>
+          </a:solidFill>
+          <a:ln>
+            <a:noFill/>
+          </a:ln>
+          <a:effectLst/>
+        </p:spPr>
+        <p:style>
+          <a:lnRef idx="1">
+            <a:schemeClr val="accent1"/>
+          </a:lnRef>
+          <a:fillRef idx="3">
+            <a:schemeClr val="accent1"/>
+          </a:fillRef>
+          <a:effectRef idx="2">
+            <a:schemeClr val="accent1"/>
+          </a:effectRef>
+          <a:fontRef idx="minor">
+            <a:schemeClr val="lt1"/>
+          </a:fontRef>
+        </p:style>
+        <p:txBody>
+          <a:bodyPr rtlCol="0" anchor="ctr"/>
+          <a:lstStyle/>
+          <a:p>
+            <a:pPr algn="ctr"/>
+          </a:p>
+        </p:txBody>
+      </p:sp>
+      <p:sp>
+        <p:nvSpPr>
+          <p:cNvPr id="7" name="Rectangle 6"/>
+          <p:cNvSpPr/>
+          <p:nvPr/>
+        </p:nvSpPr>
+        <p:spPr>
+          <a:xfrm>
+            <a:off x="777240" y="5623560"/>
+            <a:ext cx="54864" cy="731520"/>
+          </a:xfrm>
+          <a:prstGeom prst="rect">
+            <a:avLst/>
+          </a:prstGeom>
+          <a:solidFill>
+            <a:srgbClr val="EB6834"/>
+          </a:solidFill>
+          <a:ln>
+            <a:noFill/>
+          </a:ln>
+          <a:effectLst/>
+        </p:spPr>
+        <p:style>
+          <a:lnRef idx="1">
+            <a:schemeClr val="accent1"/>
+          </a:lnRef>
+          <a:fillRef idx="3">
+            <a:schemeClr val="accent1"/>
+          </a:fillRef>
+          <a:effectRef idx="2">
+            <a:schemeClr val="accent1"/>
+          </a:effectRef>
+          <a:fontRef idx="minor">
+            <a:schemeClr val="lt1"/>
+          </a:fontRef>
+        </p:style>
+        <p:txBody>
+          <a:bodyPr rtlCol="0" anchor="ctr"/>
+          <a:lstStyle/>
+          <a:p>
+            <a:pPr algn="ctr"/>
+          </a:p>
+        </p:txBody>
+      </p:sp>
+      <p:sp>
+        <p:nvSpPr>
+          <p:cNvPr id="8" name="TextBox 7"/>
+          <p:cNvSpPr txBox="1"/>
+          <p:nvPr/>
+        </p:nvSpPr>
+        <p:spPr>
+          <a:xfrm>
+            <a:off x="1051560" y="5623560"/>
+            <a:ext cx="10088575" cy="731520"/>
+          </a:xfrm>
+          <a:prstGeom prst="rect">
+            <a:avLst/>
+          </a:prstGeom>
+          <a:noFill/>
+        </p:spPr>
+        <p:txBody>
+          <a:bodyPr wrap="square" anchor="ctr" lIns="0" rIns="0" tIns="0" bIns="0">
             <a:spAutoFit/>
           </a:bodyPr>
           <a:lstStyle/>
@@ -13706,13 +13763,13 @@
               </a:spcAft>
             </a:pPr>
             <a:r>
-              <a:rPr sz="1300" b="0" i="0">
-                <a:solidFill>
-                  <a:srgbClr val="8A8983"/>
-                </a:solidFill>
-                <a:latin typeface="Helvetica Neue"/>
-              </a:rPr>
-              <a:t>SYNTHETIC REFERENCE. The right-hand bar is not a claim about Sri Lankan onion yield — it shows the same code on an adequate sample.</a:t>
+              <a:rPr sz="1500" b="1" i="0">
+                <a:solidFill>
+                  <a:srgbClr val="0D366B"/>
+                </a:solidFill>
+                <a:latin typeface="Helvetica Neue"/>
+              </a:rPr>
+              <a:t>Reporting this is better than letting a convenient negative result stand unexamined.</a:t>
             </a:r>
           </a:p>
         </p:txBody>
@@ -13866,7 +13923,7 @@
                 </a:solidFill>
                 <a:latin typeface="Helvetica Neue"/>
               </a:rPr>
-              <a:t>Contributions against the five gaps</a:t>
+              <a:t>What this work contributes</a:t>
             </a:r>
           </a:p>
         </p:txBody>
@@ -13907,7 +13964,7 @@
                           </a:solidFill>
                           <a:latin typeface="Helvetica Neue"/>
                         </a:rPr>
-                        <a:t>Gap</a:t>
+                        <a:t>Contribution</a:t>
                       </a:r>
                     </a:p>
                   </a:txBody>
@@ -13930,7 +13987,7 @@
                           </a:solidFill>
                           <a:latin typeface="Helvetica Neue"/>
                         </a:rPr>
-                        <a:t>What we delivered</a:t>
+                        <a:t>Evidence</a:t>
                       </a:r>
                     </a:p>
                   </a:txBody>
@@ -13955,7 +14012,7 @@
                           </a:solidFill>
                           <a:latin typeface="Helvetica Neue"/>
                         </a:rPr>
-                        <a:t>1  No system for big onion in Sri Lanka</a:t>
+                        <a:t>Data integrity finding</a:t>
                       </a:r>
                     </a:p>
                   </a:txBody>
@@ -13978,7 +14035,7 @@
                           </a:solidFill>
                           <a:latin typeface="Helvetica Neue"/>
                         </a:rPr>
-                        <a:t>First end-to-end pipeline, REST service and dashboard for the crop</a:t>
+                        <a:t>40% fabricated target identified and rebuilt from 87 genuine DCS records</a:t>
                       </a:r>
                     </a:p>
                   </a:txBody>
@@ -14003,7 +14060,7 @@
                           </a:solidFill>
                           <a:latin typeface="Helvetica Neue"/>
                         </a:rPr>
-                        <a:t>2  No small-sample model guidance</a:t>
+                        <a:t>A quantified account of what the panel supports</a:t>
                       </a:r>
                     </a:p>
                   </a:txBody>
@@ -14026,7 +14083,7 @@
                           </a:solidFill>
                           <a:latin typeface="Helvetica Neue"/>
                         </a:rPr>
-                        <a:t>Nine families, one protocol, paired significance tests — with a replication at larger n</a:t>
+                        <a:t>64% year / 2% district variance split; measurement error 54% of within-year; attainable R² bounded at 0.162</a:t>
                       </a:r>
                     </a:p>
                   </a:txBody>
@@ -14051,7 +14108,7 @@
                           </a:solidFill>
                           <a:latin typeface="Helvetica Neue"/>
                         </a:rPr>
-                        <a:t>3  Mechanistic + learned rarely combined</a:t>
+                        <a:t>Locally estimated agronomic coefficients</a:t>
                       </a:r>
                     </a:p>
                   </a:txBody>
@@ -14074,7 +14131,7 @@
                           </a:solidFill>
                           <a:latin typeface="Helvetica Neue"/>
                         </a:rPr>
-                        <a:t>Closed-form FAO-33 / GDD backbone + residual learner, +0.070 R², independently confirmed by stacking weights</a:t>
+                        <a:t>+0.566 R² over fixed physics; FAO-33 shown to overstate weather sensitivity ~4×</a:t>
                       </a:r>
                     </a:p>
                   </a:txBody>
@@ -14099,7 +14156,7 @@
                           </a:solidFill>
                           <a:latin typeface="Helvetica Neue"/>
                         </a:rPr>
-                        <a:t>4  Bimodal seasonality not architectural</a:t>
+                        <a:t>Diagnosis that the agro-climatic channel is inactive</a:t>
                       </a:r>
                     </a:p>
                   </a:txBody>
@@ -14122,7 +14179,7 @@
                           </a:solidFill>
                           <a:latin typeface="Helvetica Neue"/>
                         </a:rPr>
-                        <a:t>Season-injection design contributed; validation incomplete — collected data is Yala-only</a:t>
+                        <a:t>8% stress variation against 35% in yield; removing anomalous years worsens the fit</a:t>
                       </a:r>
                     </a:p>
                   </a:txBody>
@@ -14147,7 +14204,7 @@
                           </a:solidFill>
                           <a:latin typeface="Helvetica Neue"/>
                         </a:rPr>
-                        <a:t>5  No data-source decomposition</a:t>
+                        <a:t>Methodological corrections</a:t>
                       </a:r>
                     </a:p>
                   </a:txBody>
@@ -14170,7 +14227,7 @@
                           </a:solidFill>
                           <a:latin typeface="Helvetica Neue"/>
                         </a:rPr>
-                        <a:t>Six-configuration ablation on real and synthetic data, plus conformal intervals per model</a:t>
+                        <a:t>four leaks removed, fabricated sequences replaced, tautological conformal fixed, extent weighting introduced</a:t>
                       </a:r>
                     </a:p>
                   </a:txBody>
@@ -15198,7 +15255,7 @@
                 </a:solidFill>
                 <a:latin typeface="Helvetica Neue"/>
               </a:rPr>
-              <a:t>28 records is the binding constraint on every number</a:t>
+              <a:t>28 records, 4 districts, 7 years, Yala only — no Maha data exists</a:t>
             </a:r>
           </a:p>
           <a:p>
@@ -15229,7 +15286,7 @@
                 </a:solidFill>
                 <a:latin typeface="Helvetica Neue"/>
               </a:rPr>
-              <a:t>Yala only — the season-injection claim is untested on real data</a:t>
+              <a:t>Kurunegala and Matale share one weather grid cell — identical daily series</a:t>
             </a:r>
           </a:p>
           <a:p>
@@ -15260,7 +15317,7 @@
                 </a:solidFill>
                 <a:latin typeface="Helvetica Neue"/>
               </a:rPr>
-              <a:t>Conformal coverage of 1.00 is an artefact of a 28-point calibration set</a:t>
+              <a:t>Kurunegala's NDVI is a Matale proxy; its soil profile is absent entirely</a:t>
             </a:r>
           </a:p>
           <a:p>
@@ -15291,7 +15348,7 @@
                 </a:solidFill>
                 <a:latin typeface="Helvetica Neue"/>
               </a:rPr>
-              <a:t>Cultivar, irrigation, fertiliser and pest pressure are all unobserved</a:t>
+              <a:t>Six records excluded on an agronomic bound, not source verification</a:t>
             </a:r>
           </a:p>
           <a:p>
@@ -15322,7 +15379,7 @@
                 </a:solidFill>
                 <a:latin typeface="Helvetica Neue"/>
               </a:rPr>
-              <a:t>Ground-truth yield is itself subjectively estimated</a:t>
+              <a:t>The 2022 fertilizer-ban attribution is timing, not established causation</a:t>
             </a:r>
           </a:p>
           <a:p>
@@ -15353,7 +15410,7 @@
                 </a:solidFill>
                 <a:latin typeface="Helvetica Neue"/>
               </a:rPr>
-              <a:t>District-level aggregation hides within-district heterogeneity</a:t>
+              <a:t>No fertilizer, irrigation, cultivar or price data was available</a:t>
             </a:r>
           </a:p>
         </p:txBody>
@@ -15493,7 +15550,7 @@
                 </a:solidFill>
                 <a:latin typeface="Helvetica Neue"/>
               </a:rPr>
-              <a:t>Extend the record — backfill the satellite archive, add Maha and more districts</a:t>
+              <a:t>Collect input and management data — this is where the signal actually is</a:t>
             </a:r>
           </a:p>
           <a:p>
@@ -15524,7 +15581,7 @@
                 </a:solidFill>
                 <a:latin typeface="Helvetica Neue"/>
               </a:rPr>
-              <a:t>Mask satellite aggregation to cultivated onion extent, not whole districts</a:t>
+              <a:t>Re-run the ML vs DL comparison properly on the real daily sequences</a:t>
             </a:r>
           </a:p>
           <a:p>
@@ -15555,7 +15612,7 @@
                 </a:solidFill>
                 <a:latin typeface="Helvetica Neue"/>
               </a:rPr>
-              <a:t>Extend the mechanistic backbone — soil water balance, stage-dependent sensitivity</a:t>
+              <a:t>Mask satellite aggregation to cultivated onion parcels</a:t>
             </a:r>
           </a:p>
           <a:p>
@@ -15586,7 +15643,7 @@
                 </a:solidFill>
                 <a:latin typeface="Helvetica Neue"/>
               </a:rPr>
-              <a:t>Add management covariates, even coarse district-level ones</a:t>
+              <a:t>Finer reanalysis to separate Kurunegala from Matale meteorologically</a:t>
             </a:r>
           </a:p>
           <a:p>
@@ -15617,7 +15674,7 @@
                 </a:solidFill>
                 <a:latin typeface="Helvetica Neue"/>
               </a:rPr>
-              <a:t>Evaluate at operational lead time — forecast 4–8 weeks before harvest</a:t>
+              <a:t>Verify the six flagged records against the DCS publication</a:t>
             </a:r>
           </a:p>
           <a:p>
@@ -15648,7 +15705,7 @@
                 </a:solidFill>
                 <a:latin typeface="Helvetica Neue"/>
               </a:rPr>
-              <a:t>Field-validate the dashboard with DCS and district officers</a:t>
+              <a:t>Apply the ceiling calculation across published short-panel yield studies</a:t>
             </a:r>
           </a:p>
         </p:txBody>
@@ -15856,7 +15913,7 @@
                 </a:solidFill>
                 <a:latin typeface="Helvetica Neue"/>
               </a:rPr>
-              <a:t>We built the capability  </a:t>
+              <a:t>We asked whether weather predicts onion yield here  </a:t>
             </a:r>
             <a:r>
               <a:rPr sz="1550" b="0" i="0">
@@ -15865,7 +15922,7 @@
                 </a:solidFill>
                 <a:latin typeface="Helvetica Neue"/>
               </a:rPr>
-              <a:t>reproducible pipeline, nine models, leakage-free protocol, calibrated uncertainty, attribution, REST service and dashboard</a:t>
+              <a:t>and answered it: it does not, at district-season resolution</a:t>
             </a:r>
           </a:p>
           <a:p>
@@ -15896,7 +15953,7 @@
                 </a:solidFill>
                 <a:latin typeface="Helvetica Neue"/>
               </a:rPr>
-              <a:t>Best model  </a:t>
+              <a:t>The target was unattainable, and we proved it  </a:t>
             </a:r>
             <a:r>
               <a:rPr sz="1550" b="0" i="0">
@@ -15905,7 +15962,7 @@
                 </a:solidFill>
                 <a:latin typeface="Helvetica Neue"/>
               </a:rPr>
-              <a:t>physics-residual hybrid — R² 0.091, MAE 3.35 MT/Ha, 23.3% MAPE on real data</a:t>
+              <a:t>64% of variance is removed by the protocol; measurement error takes half the rest; the ceiling is 0.162</a:t>
             </a:r>
           </a:p>
           <a:p>
@@ -15936,7 +15993,7 @@
                 </a:solidFill>
                 <a:latin typeface="Helvetica Neue"/>
               </a:rPr>
-              <a:t>The 0.75 target was not met  </a:t>
+              <a:t>The mechanistic model is what made the answer possible  </a:t>
             </a:r>
             <a:r>
               <a:rPr sz="1550" b="0" i="0">
@@ -15945,7 +16002,7 @@
                 </a:solidFill>
                 <a:latin typeface="Helvetica Neue"/>
               </a:rPr>
-              <a:t>and the reason is the size of the obtainable record, not the construction of the system</a:t>
+              <a:t>a random forest scoring −0.56 tells you nothing; PADR reports which mechanisms are inactive and by how much</a:t>
             </a:r>
           </a:p>
           <a:p>
@@ -15976,7 +16033,7 @@
                 </a:solidFill>
                 <a:latin typeface="Helvetica Neue"/>
               </a:rPr>
-              <a:t>The durable findings are methodological  </a:t>
+              <a:t>One transferable positive result  </a:t>
             </a:r>
             <a:r>
               <a:rPr sz="1550" b="0" i="0">
@@ -15985,7 +16042,7 @@
                 </a:solidFill>
                 <a:latin typeface="Helvetica Neue"/>
               </a:rPr>
-              <a:t>deep learning fails at this scale; a lightweight agronomic prior measurably helps; estimated blend weights beat uniform averaging; engineered interactions outrank raw measurements</a:t>
+              <a:t>FAO-33 coefficients overstate weather sensitivity for big onion under tank irrigation — calibrate locally</a:t>
             </a:r>
           </a:p>
           <a:p>
@@ -16016,7 +16073,7 @@
                 </a:solidFill>
                 <a:latin typeface="Helvetica Neue"/>
               </a:rPr>
-              <a:t>The path forward is concrete  </a:t>
+              <a:t>We corrected our own record  </a:t>
             </a:r>
             <a:r>
               <a:rPr sz="1550" b="0" i="0">
@@ -16025,7 +16082,7 @@
                 </a:solidFill>
                 <a:latin typeface="Helvetica Neue"/>
               </a:rPr>
-              <a:t>a longer record, a crop mask, a fuller backbone, management covariates</a:t>
+              <a:t>a fabricated target, a manufactured input tensor and a tautological uncertainty calculation, all found and reported</a:t>
             </a:r>
           </a:p>
         </p:txBody>
@@ -16155,7 +16212,7 @@
                 </a:solidFill>
                 <a:latin typeface="Helvetica Neue"/>
               </a:rPr>
-              <a:t>Accuracy is bounded by an information constraint, not an engineering one — and we can name what would lift it.</a:t>
+              <a:t>A well-diagnosed negative result, with its errors stated openly, is worth more than a favourable number that cannot be defended.</a:t>
             </a:r>
           </a:p>
         </p:txBody>
@@ -19680,7 +19737,7 @@
                 </a:solidFill>
                 <a:latin typeface="Helvetica Neue"/>
               </a:rPr>
-              <a:t>Four data streams reduced to one grain, 32 engineered predictors, nine models, and an evaluation protocol built to not flatter us.</a:t>
+              <a:t>Four data streams reduced to one grain, 37,988 real daily weather records, and an evaluation protocol built to not flatter us.</a:t>
             </a:r>
           </a:p>
         </p:txBody>

</xml_diff>